<commit_message>
Revise zVAS margin slide: tiered GAPIT-from-VNG discount minus agent discount
- GAPIT discount from VNG: 100-299=15%, >=300=20%; agent/KHDN discount 5/8/10%
- GAPIT net margin = VNG discount - agent discount (matrix 2x3 + examples)
- Remove tier-II agent concept: only GAPIT and GAPIT's agents/KHDN

https://claude.ai/code/session_0133sCYP62GY9C9jKN3N5vJE
</commit_message>
<xml_diff>
--- a/output/GAPIT_zVAS_Business_Roadmap_3slides.pptx
+++ b/output/GAPIT_zVAS_Business_Roadmap_3slides.pptx
@@ -3891,7 +3891,7 @@
                 </a:solidFill>
                 <a:latin typeface="Calibri"/>
               </a:rPr>
-              <a:t>Go-live KHDN + ký HĐ Đại lý cấp II; DPA theo mẫu PDPA(VNI)</a:t>
+              <a:t>Go-live KHDN + ký HĐ Đại lý của GAPIT; DPA theo mẫu PDPA(VNI)</a:t>
             </a:r>
           </a:p>
           <a:p>
@@ -4285,7 +4285,7 @@
                 </a:solidFill>
                 <a:latin typeface="Calibri"/>
               </a:rPr>
-              <a:t>Mở rộng Đại lý cấp II: RACI, onboarding, KPI doanh số tối thiểu</a:t>
+              <a:t>Mở rộng mạng Đại lý của GAPIT: RACI, onboarding, KPI doanh số tối thiểu</a:t>
             </a:r>
           </a:p>
           <a:p>
@@ -5130,7 +5130,7 @@
                 </a:solidFill>
                 <a:latin typeface="Arial"/>
               </a:rPr>
-              <a:t>Biên Lợi Nhuận — GAPIT &amp; Đại Lý Cấp II</a:t>
+              <a:t>Biên Lợi Nhuận — GAPIT &amp; Đại lý của GAPIT</a:t>
             </a:r>
           </a:p>
         </p:txBody>
@@ -5169,13 +5169,13 @@
               </a:spcAft>
             </a:pPr>
             <a:r>
-              <a:rPr sz="1100" b="0">
+              <a:rPr sz="1050" b="0">
                 <a:solidFill>
                   <a:srgbClr val="718096"/>
                 </a:solidFill>
                 <a:latin typeface="Calibri"/>
               </a:rPr>
-              <a:t>Tổng biên kênh ≈ 20% (chênh giá bán lẻ Zalo vs giá VNG cấp cho GAPIT) · GAPIT giữ = 20% − chiết khấu cấp cho Đại lý cấp II.</a:t>
+              <a:t>Biên GAPIT = tuần tự trừ:  Chiết khấu GAPIT NHẬN từ VNG  −  Chiết khấu GAPIT CẤP cho Đại lý/KHDN.  (Chỉ có GAPIT và Đại lý của GAPIT — không có đại lý cấp II.)</a:t>
             </a:r>
           </a:p>
         </p:txBody>
@@ -5280,14 +5280,60 @@
       </p:sp>
       <p:sp>
         <p:nvSpPr>
-          <p:cNvPr id="11" name="Rectangle 10"/>
+          <p:cNvPr id="11" name="Rounded Rectangle 10"/>
           <p:cNvSpPr/>
           <p:nvPr/>
         </p:nvSpPr>
         <p:spPr>
           <a:xfrm>
-            <a:off x="411480" y="1627632"/>
-            <a:ext cx="1874519" cy="457200"/>
+            <a:off x="411480" y="1463040"/>
+            <a:ext cx="5577840" cy="841248"/>
+          </a:xfrm>
+          <a:prstGeom prst="roundRect">
+            <a:avLst/>
+          </a:prstGeom>
+          <a:solidFill>
+            <a:srgbClr val="FFFFFF"/>
+          </a:solidFill>
+          <a:ln w="15875">
+            <a:solidFill>
+              <a:srgbClr val="003F88"/>
+            </a:solidFill>
+          </a:ln>
+          <a:effectLst/>
+        </p:spPr>
+        <p:style>
+          <a:lnRef idx="1">
+            <a:schemeClr val="accent1"/>
+          </a:lnRef>
+          <a:fillRef idx="3">
+            <a:schemeClr val="accent1"/>
+          </a:fillRef>
+          <a:effectRef idx="2">
+            <a:schemeClr val="accent1"/>
+          </a:effectRef>
+          <a:fontRef idx="minor">
+            <a:schemeClr val="lt1"/>
+          </a:fontRef>
+        </p:style>
+        <p:txBody>
+          <a:bodyPr rtlCol="0" anchor="ctr"/>
+          <a:lstStyle/>
+          <a:p>
+            <a:pPr algn="ctr"/>
+          </a:p>
+        </p:txBody>
+      </p:sp>
+      <p:sp>
+        <p:nvSpPr>
+          <p:cNvPr id="12" name="Rectangle 11"/>
+          <p:cNvSpPr/>
+          <p:nvPr/>
+        </p:nvSpPr>
+        <p:spPr>
+          <a:xfrm>
+            <a:off x="411480" y="1463040"/>
+            <a:ext cx="91440" cy="841248"/>
           </a:xfrm>
           <a:prstGeom prst="rect">
             <a:avLst/>
@@ -5324,14 +5370,409 @@
       </p:sp>
       <p:sp>
         <p:nvSpPr>
-          <p:cNvPr id="12" name="TextBox 11"/>
+          <p:cNvPr id="13" name="TextBox 12"/>
           <p:cNvSpPr txBox="1"/>
           <p:nvPr/>
         </p:nvSpPr>
         <p:spPr>
           <a:xfrm>
-            <a:off x="411480" y="1627632"/>
-            <a:ext cx="1874519" cy="457200"/>
+            <a:off x="630936" y="1508760"/>
+            <a:ext cx="5212080" cy="310896"/>
+          </a:xfrm>
+          <a:prstGeom prst="rect">
+            <a:avLst/>
+          </a:prstGeom>
+          <a:noFill/>
+        </p:spPr>
+        <p:txBody>
+          <a:bodyPr wrap="square" anchor="t" lIns="45720" rIns="45720" tIns="18288" bIns="9144">
+            <a:spAutoFit/>
+          </a:bodyPr>
+          <a:lstStyle/>
+          <a:p>
+            <a:pPr algn="l">
+              <a:lnSpc>
+                <a:spcPct val="103000"/>
+              </a:lnSpc>
+              <a:spcBef>
+                <a:spcPts val="0"/>
+              </a:spcBef>
+              <a:spcAft>
+                <a:spcPts val="0"/>
+              </a:spcAft>
+            </a:pPr>
+            <a:r>
+              <a:rPr sz="1000" b="1">
+                <a:solidFill>
+                  <a:srgbClr val="003F88"/>
+                </a:solidFill>
+                <a:latin typeface="Calibri"/>
+              </a:rPr>
+              <a:t>①  GAPIT NHẬN từ VNG  (theo SL GAPIT đặt)</a:t>
+            </a:r>
+          </a:p>
+        </p:txBody>
+      </p:sp>
+      <p:sp>
+        <p:nvSpPr>
+          <p:cNvPr id="14" name="TextBox 13"/>
+          <p:cNvSpPr txBox="1"/>
+          <p:nvPr/>
+        </p:nvSpPr>
+        <p:spPr>
+          <a:xfrm>
+            <a:off x="630936" y="1847088"/>
+            <a:ext cx="5212080" cy="402336"/>
+          </a:xfrm>
+          <a:prstGeom prst="rect">
+            <a:avLst/>
+          </a:prstGeom>
+          <a:noFill/>
+        </p:spPr>
+        <p:txBody>
+          <a:bodyPr wrap="square" anchor="t" lIns="45720" rIns="45720" tIns="18288" bIns="9144">
+            <a:spAutoFit/>
+          </a:bodyPr>
+          <a:lstStyle/>
+          <a:p>
+            <a:pPr algn="l">
+              <a:lnSpc>
+                <a:spcPct val="103000"/>
+              </a:lnSpc>
+              <a:spcBef>
+                <a:spcPts val="0"/>
+              </a:spcBef>
+              <a:spcAft>
+                <a:spcPts val="0"/>
+              </a:spcAft>
+            </a:pPr>
+            <a:r>
+              <a:rPr sz="1250" b="1">
+                <a:solidFill>
+                  <a:srgbClr val="001A40"/>
+                </a:solidFill>
+                <a:latin typeface="Calibri"/>
+              </a:rPr>
+              <a:t>100–299 code: 15%          ·          ≥ 300 code: 20%</a:t>
+            </a:r>
+          </a:p>
+        </p:txBody>
+      </p:sp>
+      <p:sp>
+        <p:nvSpPr>
+          <p:cNvPr id="15" name="Rounded Rectangle 14"/>
+          <p:cNvSpPr/>
+          <p:nvPr/>
+        </p:nvSpPr>
+        <p:spPr>
+          <a:xfrm>
+            <a:off x="6199632" y="1463040"/>
+            <a:ext cx="5577840" cy="841248"/>
+          </a:xfrm>
+          <a:prstGeom prst="roundRect">
+            <a:avLst/>
+          </a:prstGeom>
+          <a:solidFill>
+            <a:srgbClr val="FFFFFF"/>
+          </a:solidFill>
+          <a:ln w="15875">
+            <a:solidFill>
+              <a:srgbClr val="0F6E56"/>
+            </a:solidFill>
+          </a:ln>
+          <a:effectLst/>
+        </p:spPr>
+        <p:style>
+          <a:lnRef idx="1">
+            <a:schemeClr val="accent1"/>
+          </a:lnRef>
+          <a:fillRef idx="3">
+            <a:schemeClr val="accent1"/>
+          </a:fillRef>
+          <a:effectRef idx="2">
+            <a:schemeClr val="accent1"/>
+          </a:effectRef>
+          <a:fontRef idx="minor">
+            <a:schemeClr val="lt1"/>
+          </a:fontRef>
+        </p:style>
+        <p:txBody>
+          <a:bodyPr rtlCol="0" anchor="ctr"/>
+          <a:lstStyle/>
+          <a:p>
+            <a:pPr algn="ctr"/>
+          </a:p>
+        </p:txBody>
+      </p:sp>
+      <p:sp>
+        <p:nvSpPr>
+          <p:cNvPr id="16" name="Rectangle 15"/>
+          <p:cNvSpPr/>
+          <p:nvPr/>
+        </p:nvSpPr>
+        <p:spPr>
+          <a:xfrm>
+            <a:off x="6199632" y="1463040"/>
+            <a:ext cx="91440" cy="841248"/>
+          </a:xfrm>
+          <a:prstGeom prst="rect">
+            <a:avLst/>
+          </a:prstGeom>
+          <a:solidFill>
+            <a:srgbClr val="0F6E56"/>
+          </a:solidFill>
+          <a:ln>
+            <a:noFill/>
+          </a:ln>
+          <a:effectLst/>
+        </p:spPr>
+        <p:style>
+          <a:lnRef idx="1">
+            <a:schemeClr val="accent1"/>
+          </a:lnRef>
+          <a:fillRef idx="3">
+            <a:schemeClr val="accent1"/>
+          </a:fillRef>
+          <a:effectRef idx="2">
+            <a:schemeClr val="accent1"/>
+          </a:effectRef>
+          <a:fontRef idx="minor">
+            <a:schemeClr val="lt1"/>
+          </a:fontRef>
+        </p:style>
+        <p:txBody>
+          <a:bodyPr rtlCol="0" anchor="ctr"/>
+          <a:lstStyle/>
+          <a:p>
+            <a:pPr algn="ctr"/>
+          </a:p>
+        </p:txBody>
+      </p:sp>
+      <p:sp>
+        <p:nvSpPr>
+          <p:cNvPr id="17" name="TextBox 16"/>
+          <p:cNvSpPr txBox="1"/>
+          <p:nvPr/>
+        </p:nvSpPr>
+        <p:spPr>
+          <a:xfrm>
+            <a:off x="6419088" y="1508760"/>
+            <a:ext cx="5212080" cy="310896"/>
+          </a:xfrm>
+          <a:prstGeom prst="rect">
+            <a:avLst/>
+          </a:prstGeom>
+          <a:noFill/>
+        </p:spPr>
+        <p:txBody>
+          <a:bodyPr wrap="square" anchor="t" lIns="45720" rIns="45720" tIns="18288" bIns="9144">
+            <a:spAutoFit/>
+          </a:bodyPr>
+          <a:lstStyle/>
+          <a:p>
+            <a:pPr algn="l">
+              <a:lnSpc>
+                <a:spcPct val="103000"/>
+              </a:lnSpc>
+              <a:spcBef>
+                <a:spcPts val="0"/>
+              </a:spcBef>
+              <a:spcAft>
+                <a:spcPts val="0"/>
+              </a:spcAft>
+            </a:pPr>
+            <a:r>
+              <a:rPr sz="1000" b="1">
+                <a:solidFill>
+                  <a:srgbClr val="0F6E56"/>
+                </a:solidFill>
+                <a:latin typeface="Calibri"/>
+              </a:rPr>
+              <a:t>②  GAPIT CẤP cho Đại lý / KHDN  (theo SL của ĐL/KHDN)</a:t>
+            </a:r>
+          </a:p>
+        </p:txBody>
+      </p:sp>
+      <p:sp>
+        <p:nvSpPr>
+          <p:cNvPr id="18" name="TextBox 17"/>
+          <p:cNvSpPr txBox="1"/>
+          <p:nvPr/>
+        </p:nvSpPr>
+        <p:spPr>
+          <a:xfrm>
+            <a:off x="6419088" y="1847088"/>
+            <a:ext cx="5212080" cy="402336"/>
+          </a:xfrm>
+          <a:prstGeom prst="rect">
+            <a:avLst/>
+          </a:prstGeom>
+          <a:noFill/>
+        </p:spPr>
+        <p:txBody>
+          <a:bodyPr wrap="square" anchor="t" lIns="45720" rIns="45720" tIns="18288" bIns="9144">
+            <a:spAutoFit/>
+          </a:bodyPr>
+          <a:lstStyle/>
+          <a:p>
+            <a:pPr algn="l">
+              <a:lnSpc>
+                <a:spcPct val="103000"/>
+              </a:lnSpc>
+              <a:spcBef>
+                <a:spcPts val="0"/>
+              </a:spcBef>
+              <a:spcAft>
+                <a:spcPts val="0"/>
+              </a:spcAft>
+            </a:pPr>
+            <a:r>
+              <a:rPr sz="1250" b="1">
+                <a:solidFill>
+                  <a:srgbClr val="001A40"/>
+                </a:solidFill>
+                <a:latin typeface="Calibri"/>
+              </a:rPr>
+              <a:t>50–99: 5%        ·        100–299: 8%        ·        ≥ 300: 10%</a:t>
+            </a:r>
+          </a:p>
+        </p:txBody>
+      </p:sp>
+      <p:sp>
+        <p:nvSpPr>
+          <p:cNvPr id="19" name="TextBox 18"/>
+          <p:cNvSpPr txBox="1"/>
+          <p:nvPr/>
+        </p:nvSpPr>
+        <p:spPr>
+          <a:xfrm>
+            <a:off x="411480" y="2395728"/>
+            <a:ext cx="11338560" cy="219456"/>
+          </a:xfrm>
+          <a:prstGeom prst="rect">
+            <a:avLst/>
+          </a:prstGeom>
+          <a:noFill/>
+        </p:spPr>
+        <p:txBody>
+          <a:bodyPr wrap="square" anchor="t" lIns="45720" rIns="45720" tIns="18288" bIns="9144">
+            <a:spAutoFit/>
+          </a:bodyPr>
+          <a:lstStyle/>
+          <a:p>
+            <a:pPr algn="l">
+              <a:lnSpc>
+                <a:spcPct val="103000"/>
+              </a:lnSpc>
+              <a:spcBef>
+                <a:spcPts val="0"/>
+              </a:spcBef>
+              <a:spcAft>
+                <a:spcPts val="0"/>
+              </a:spcAft>
+            </a:pPr>
+            <a:r>
+              <a:rPr sz="1000" b="1">
+                <a:solidFill>
+                  <a:srgbClr val="718096"/>
+                </a:solidFill>
+                <a:latin typeface="Calibri"/>
+              </a:rPr>
+              <a:t>Biên GAPIT giữ lại  =  ①  −  ②        (mỗi ô:  </a:t>
+            </a:r>
+            <a:r>
+              <a:rPr sz="1000" b="1">
+                <a:solidFill>
+                  <a:srgbClr val="F5862C"/>
+                </a:solidFill>
+                <a:latin typeface="Calibri"/>
+              </a:rPr>
+              <a:t>Biên GAPIT</a:t>
+            </a:r>
+            <a:r>
+              <a:rPr sz="1000" b="1">
+                <a:solidFill>
+                  <a:srgbClr val="718096"/>
+                </a:solidFill>
+                <a:latin typeface="Calibri"/>
+              </a:rPr>
+              <a:t>  /  </a:t>
+            </a:r>
+            <a:r>
+              <a:rPr sz="1000" b="1">
+                <a:solidFill>
+                  <a:srgbClr val="22C55E"/>
+                </a:solidFill>
+                <a:latin typeface="Calibri"/>
+              </a:rPr>
+              <a:t>Biên Đại lý/KHDN</a:t>
+            </a:r>
+            <a:r>
+              <a:rPr sz="1000" b="1">
+                <a:solidFill>
+                  <a:srgbClr val="718096"/>
+                </a:solidFill>
+                <a:latin typeface="Calibri"/>
+              </a:rPr>
+              <a:t> )</a:t>
+            </a:r>
+          </a:p>
+        </p:txBody>
+      </p:sp>
+      <p:sp>
+        <p:nvSpPr>
+          <p:cNvPr id="20" name="Rectangle 19"/>
+          <p:cNvSpPr/>
+          <p:nvPr/>
+        </p:nvSpPr>
+        <p:spPr>
+          <a:xfrm>
+            <a:off x="411480" y="2651760"/>
+            <a:ext cx="3017520" cy="548640"/>
+          </a:xfrm>
+          <a:prstGeom prst="rect">
+            <a:avLst/>
+          </a:prstGeom>
+          <a:solidFill>
+            <a:srgbClr val="001A40"/>
+          </a:solidFill>
+          <a:ln>
+            <a:noFill/>
+          </a:ln>
+          <a:effectLst/>
+        </p:spPr>
+        <p:style>
+          <a:lnRef idx="1">
+            <a:schemeClr val="accent1"/>
+          </a:lnRef>
+          <a:fillRef idx="3">
+            <a:schemeClr val="accent1"/>
+          </a:fillRef>
+          <a:effectRef idx="2">
+            <a:schemeClr val="accent1"/>
+          </a:effectRef>
+          <a:fontRef idx="minor">
+            <a:schemeClr val="lt1"/>
+          </a:fontRef>
+        </p:style>
+        <p:txBody>
+          <a:bodyPr rtlCol="0" anchor="ctr"/>
+          <a:lstStyle/>
+          <a:p>
+            <a:pPr algn="ctr"/>
+          </a:p>
+        </p:txBody>
+      </p:sp>
+      <p:sp>
+        <p:nvSpPr>
+          <p:cNvPr id="21" name="TextBox 20"/>
+          <p:cNvSpPr txBox="1"/>
+          <p:nvPr/>
+        </p:nvSpPr>
+        <p:spPr>
+          <a:xfrm>
+            <a:off x="411480" y="2651760"/>
+            <a:ext cx="3017520" cy="548640"/>
           </a:xfrm>
           <a:prstGeom prst="rect">
             <a:avLst/>
@@ -5356,27 +5797,27 @@
               </a:spcAft>
             </a:pPr>
             <a:r>
-              <a:rPr sz="1000" b="1">
+              <a:rPr sz="900" b="1">
                 <a:solidFill>
                   <a:srgbClr val="FFFFFF"/>
                 </a:solidFill>
                 <a:latin typeface="Calibri"/>
               </a:rPr>
-              <a:t>Bậc SL (code/tháng)</a:t>
-            </a:r>
-          </a:p>
-        </p:txBody>
-      </p:sp>
-      <p:sp>
-        <p:nvSpPr>
-          <p:cNvPr id="13" name="Rectangle 12"/>
+              <a:t>GAPIT mua ↓   \   ĐL/KHDN →</a:t>
+            </a:r>
+          </a:p>
+        </p:txBody>
+      </p:sp>
+      <p:sp>
+        <p:nvSpPr>
+          <p:cNvPr id="22" name="Rectangle 21"/>
           <p:cNvSpPr/>
           <p:nvPr/>
         </p:nvSpPr>
         <p:spPr>
           <a:xfrm>
-            <a:off x="2286000" y="1627632"/>
-            <a:ext cx="1691640" cy="457200"/>
+            <a:off x="3429000" y="2651760"/>
+            <a:ext cx="2194560" cy="548640"/>
           </a:xfrm>
           <a:prstGeom prst="rect">
             <a:avLst/>
@@ -5413,14 +5854,14 @@
       </p:sp>
       <p:sp>
         <p:nvSpPr>
-          <p:cNvPr id="14" name="TextBox 13"/>
+          <p:cNvPr id="23" name="TextBox 22"/>
           <p:cNvSpPr txBox="1"/>
           <p:nvPr/>
         </p:nvSpPr>
         <p:spPr>
           <a:xfrm>
-            <a:off x="2286000" y="1627632"/>
-            <a:ext cx="1691640" cy="457200"/>
+            <a:off x="3429000" y="2651760"/>
+            <a:ext cx="2194560" cy="548640"/>
           </a:xfrm>
           <a:prstGeom prst="rect">
             <a:avLst/>
@@ -5445,27 +5886,27 @@
               </a:spcAft>
             </a:pPr>
             <a:r>
-              <a:rPr sz="1000" b="1">
+              <a:rPr sz="860" b="1">
                 <a:solidFill>
                   <a:srgbClr val="FFFFFF"/>
                 </a:solidFill>
                 <a:latin typeface="Calibri"/>
               </a:rPr>
-              <a:t>CK Đại lý cấp II</a:t>
-            </a:r>
-          </a:p>
-        </p:txBody>
-      </p:sp>
-      <p:sp>
-        <p:nvSpPr>
-          <p:cNvPr id="15" name="Rectangle 14"/>
+              <a:t>ĐL/KHDN 50–99  (CK 5%)</a:t>
+            </a:r>
+          </a:p>
+        </p:txBody>
+      </p:sp>
+      <p:sp>
+        <p:nvSpPr>
+          <p:cNvPr id="24" name="Rectangle 23"/>
           <p:cNvSpPr/>
           <p:nvPr/>
         </p:nvSpPr>
         <p:spPr>
           <a:xfrm>
-            <a:off x="3977639" y="1627632"/>
-            <a:ext cx="1554480" cy="457200"/>
+            <a:off x="5623560" y="2651760"/>
+            <a:ext cx="2194560" cy="548640"/>
           </a:xfrm>
           <a:prstGeom prst="rect">
             <a:avLst/>
@@ -5502,14 +5943,14 @@
       </p:sp>
       <p:sp>
         <p:nvSpPr>
-          <p:cNvPr id="16" name="TextBox 15"/>
+          <p:cNvPr id="25" name="TextBox 24"/>
           <p:cNvSpPr txBox="1"/>
           <p:nvPr/>
         </p:nvSpPr>
         <p:spPr>
           <a:xfrm>
-            <a:off x="3977639" y="1627632"/>
-            <a:ext cx="1554480" cy="457200"/>
+            <a:off x="5623560" y="2651760"/>
+            <a:ext cx="2194560" cy="548640"/>
           </a:xfrm>
           <a:prstGeom prst="rect">
             <a:avLst/>
@@ -5534,27 +5975,27 @@
               </a:spcAft>
             </a:pPr>
             <a:r>
-              <a:rPr sz="1000" b="1">
+              <a:rPr sz="860" b="1">
                 <a:solidFill>
                   <a:srgbClr val="FFFFFF"/>
                 </a:solidFill>
                 <a:latin typeface="Calibri"/>
               </a:rPr>
-              <a:t>Biên Đại lý II</a:t>
-            </a:r>
-          </a:p>
-        </p:txBody>
-      </p:sp>
-      <p:sp>
-        <p:nvSpPr>
-          <p:cNvPr id="17" name="Rectangle 16"/>
+              <a:t>100–299  (CK 8%)</a:t>
+            </a:r>
+          </a:p>
+        </p:txBody>
+      </p:sp>
+      <p:sp>
+        <p:nvSpPr>
+          <p:cNvPr id="26" name="Rectangle 25"/>
           <p:cNvSpPr/>
           <p:nvPr/>
         </p:nvSpPr>
         <p:spPr>
           <a:xfrm>
-            <a:off x="5532120" y="1627632"/>
-            <a:ext cx="1783080" cy="457200"/>
+            <a:off x="7818120" y="2651760"/>
+            <a:ext cx="2194560" cy="548640"/>
           </a:xfrm>
           <a:prstGeom prst="rect">
             <a:avLst/>
@@ -5591,14 +6032,14 @@
       </p:sp>
       <p:sp>
         <p:nvSpPr>
-          <p:cNvPr id="18" name="TextBox 17"/>
+          <p:cNvPr id="27" name="TextBox 26"/>
           <p:cNvSpPr txBox="1"/>
           <p:nvPr/>
         </p:nvSpPr>
         <p:spPr>
           <a:xfrm>
-            <a:off x="5532120" y="1627632"/>
-            <a:ext cx="1783080" cy="457200"/>
+            <a:off x="7818120" y="2651760"/>
+            <a:ext cx="2194560" cy="548640"/>
           </a:xfrm>
           <a:prstGeom prst="rect">
             <a:avLst/>
@@ -5623,36 +6064,38 @@
               </a:spcAft>
             </a:pPr>
             <a:r>
-              <a:rPr sz="1000" b="1">
+              <a:rPr sz="860" b="1">
                 <a:solidFill>
                   <a:srgbClr val="FFFFFF"/>
                 </a:solidFill>
                 <a:latin typeface="Calibri"/>
               </a:rPr>
-              <a:t>Biên GAPIT giữ</a:t>
-            </a:r>
-          </a:p>
-        </p:txBody>
-      </p:sp>
-      <p:sp>
-        <p:nvSpPr>
-          <p:cNvPr id="19" name="Rectangle 18"/>
+              <a:t>≥ 300  (CK 10%)</a:t>
+            </a:r>
+          </a:p>
+        </p:txBody>
+      </p:sp>
+      <p:sp>
+        <p:nvSpPr>
+          <p:cNvPr id="28" name="Rectangle 27"/>
           <p:cNvSpPr/>
           <p:nvPr/>
         </p:nvSpPr>
         <p:spPr>
           <a:xfrm>
-            <a:off x="7315200" y="1627632"/>
-            <a:ext cx="1234440" cy="457200"/>
+            <a:off x="411480" y="3200400"/>
+            <a:ext cx="3017520" cy="548640"/>
           </a:xfrm>
           <a:prstGeom prst="rect">
             <a:avLst/>
           </a:prstGeom>
           <a:solidFill>
-            <a:srgbClr val="003F88"/>
+            <a:srgbClr val="EAF0F8"/>
           </a:solidFill>
-          <a:ln>
-            <a:noFill/>
+          <a:ln w="6350">
+            <a:solidFill>
+              <a:srgbClr val="E2E8F0"/>
+            </a:solidFill>
           </a:ln>
           <a:effectLst/>
         </p:spPr>
@@ -5680,14 +6123,14 @@
       </p:sp>
       <p:sp>
         <p:nvSpPr>
-          <p:cNvPr id="20" name="TextBox 19"/>
+          <p:cNvPr id="29" name="TextBox 28"/>
           <p:cNvSpPr txBox="1"/>
           <p:nvPr/>
         </p:nvSpPr>
         <p:spPr>
           <a:xfrm>
-            <a:off x="7315200" y="1627632"/>
-            <a:ext cx="1234440" cy="457200"/>
+            <a:off x="411480" y="3200400"/>
+            <a:ext cx="3017520" cy="548640"/>
           </a:xfrm>
           <a:prstGeom prst="rect">
             <a:avLst/>
@@ -5712,27 +6155,445 @@
               </a:spcAft>
             </a:pPr>
             <a:r>
-              <a:rPr sz="1000" b="1">
-                <a:solidFill>
-                  <a:srgbClr val="FFFFFF"/>
-                </a:solidFill>
-                <a:latin typeface="Calibri"/>
-              </a:rPr>
-              <a:t>Tổng biên kênh</a:t>
-            </a:r>
-          </a:p>
-        </p:txBody>
-      </p:sp>
-      <p:sp>
-        <p:nvSpPr>
-          <p:cNvPr id="21" name="Rectangle 20"/>
+              <a:rPr sz="950" b="1">
+                <a:solidFill>
+                  <a:srgbClr val="001A40"/>
+                </a:solidFill>
+                <a:latin typeface="Calibri"/>
+              </a:rPr>
+              <a:t>≥ 300  (GAPIT −20%)</a:t>
+            </a:r>
+          </a:p>
+        </p:txBody>
+      </p:sp>
+      <p:sp>
+        <p:nvSpPr>
+          <p:cNvPr id="30" name="Rectangle 29"/>
           <p:cNvSpPr/>
           <p:nvPr/>
         </p:nvSpPr>
         <p:spPr>
           <a:xfrm>
-            <a:off x="411480" y="2084832"/>
-            <a:ext cx="1874519" cy="457200"/>
+            <a:off x="3429000" y="3200400"/>
+            <a:ext cx="2194560" cy="548640"/>
+          </a:xfrm>
+          <a:prstGeom prst="rect">
+            <a:avLst/>
+          </a:prstGeom>
+          <a:solidFill>
+            <a:srgbClr val="FFF6E9"/>
+          </a:solidFill>
+          <a:ln w="6350">
+            <a:solidFill>
+              <a:srgbClr val="E2E8F0"/>
+            </a:solidFill>
+          </a:ln>
+          <a:effectLst/>
+        </p:spPr>
+        <p:style>
+          <a:lnRef idx="1">
+            <a:schemeClr val="accent1"/>
+          </a:lnRef>
+          <a:fillRef idx="3">
+            <a:schemeClr val="accent1"/>
+          </a:fillRef>
+          <a:effectRef idx="2">
+            <a:schemeClr val="accent1"/>
+          </a:effectRef>
+          <a:fontRef idx="minor">
+            <a:schemeClr val="lt1"/>
+          </a:fontRef>
+        </p:style>
+        <p:txBody>
+          <a:bodyPr rtlCol="0" anchor="ctr"/>
+          <a:lstStyle/>
+          <a:p>
+            <a:pPr algn="ctr"/>
+          </a:p>
+        </p:txBody>
+      </p:sp>
+      <p:sp>
+        <p:nvSpPr>
+          <p:cNvPr id="31" name="TextBox 30"/>
+          <p:cNvSpPr txBox="1"/>
+          <p:nvPr/>
+        </p:nvSpPr>
+        <p:spPr>
+          <a:xfrm>
+            <a:off x="3429000" y="3200400"/>
+            <a:ext cx="2194560" cy="548640"/>
+          </a:xfrm>
+          <a:prstGeom prst="rect">
+            <a:avLst/>
+          </a:prstGeom>
+          <a:noFill/>
+        </p:spPr>
+        <p:txBody>
+          <a:bodyPr wrap="square" anchor="ctr" lIns="45720" rIns="45720" tIns="18288" bIns="9144">
+            <a:spAutoFit/>
+          </a:bodyPr>
+          <a:lstStyle/>
+          <a:p>
+            <a:pPr algn="ctr">
+              <a:lnSpc>
+                <a:spcPct val="103000"/>
+              </a:lnSpc>
+              <a:spcBef>
+                <a:spcPts val="0"/>
+              </a:spcBef>
+              <a:spcAft>
+                <a:spcPts val="0"/>
+              </a:spcAft>
+            </a:pPr>
+            <a:r>
+              <a:rPr sz="1150" b="1">
+                <a:solidFill>
+                  <a:srgbClr val="F5862C"/>
+                </a:solidFill>
+                <a:latin typeface="Calibri"/>
+              </a:rPr>
+              <a:t>15%</a:t>
+            </a:r>
+            <a:r>
+              <a:rPr sz="1150" b="0">
+                <a:solidFill>
+                  <a:srgbClr val="718096"/>
+                </a:solidFill>
+                <a:latin typeface="Calibri"/>
+              </a:rPr>
+              <a:t>  /  </a:t>
+            </a:r>
+            <a:r>
+              <a:rPr sz="1150" b="1">
+                <a:solidFill>
+                  <a:srgbClr val="22C55E"/>
+                </a:solidFill>
+                <a:latin typeface="Calibri"/>
+              </a:rPr>
+              <a:t>5%</a:t>
+            </a:r>
+          </a:p>
+        </p:txBody>
+      </p:sp>
+      <p:sp>
+        <p:nvSpPr>
+          <p:cNvPr id="32" name="Rectangle 31"/>
+          <p:cNvSpPr/>
+          <p:nvPr/>
+        </p:nvSpPr>
+        <p:spPr>
+          <a:xfrm>
+            <a:off x="5623560" y="3200400"/>
+            <a:ext cx="2194560" cy="548640"/>
+          </a:xfrm>
+          <a:prstGeom prst="rect">
+            <a:avLst/>
+          </a:prstGeom>
+          <a:solidFill>
+            <a:srgbClr val="FFF6E9"/>
+          </a:solidFill>
+          <a:ln w="6350">
+            <a:solidFill>
+              <a:srgbClr val="E2E8F0"/>
+            </a:solidFill>
+          </a:ln>
+          <a:effectLst/>
+        </p:spPr>
+        <p:style>
+          <a:lnRef idx="1">
+            <a:schemeClr val="accent1"/>
+          </a:lnRef>
+          <a:fillRef idx="3">
+            <a:schemeClr val="accent1"/>
+          </a:fillRef>
+          <a:effectRef idx="2">
+            <a:schemeClr val="accent1"/>
+          </a:effectRef>
+          <a:fontRef idx="minor">
+            <a:schemeClr val="lt1"/>
+          </a:fontRef>
+        </p:style>
+        <p:txBody>
+          <a:bodyPr rtlCol="0" anchor="ctr"/>
+          <a:lstStyle/>
+          <a:p>
+            <a:pPr algn="ctr"/>
+          </a:p>
+        </p:txBody>
+      </p:sp>
+      <p:sp>
+        <p:nvSpPr>
+          <p:cNvPr id="33" name="TextBox 32"/>
+          <p:cNvSpPr txBox="1"/>
+          <p:nvPr/>
+        </p:nvSpPr>
+        <p:spPr>
+          <a:xfrm>
+            <a:off x="5623560" y="3200400"/>
+            <a:ext cx="2194560" cy="548640"/>
+          </a:xfrm>
+          <a:prstGeom prst="rect">
+            <a:avLst/>
+          </a:prstGeom>
+          <a:noFill/>
+        </p:spPr>
+        <p:txBody>
+          <a:bodyPr wrap="square" anchor="ctr" lIns="45720" rIns="45720" tIns="18288" bIns="9144">
+            <a:spAutoFit/>
+          </a:bodyPr>
+          <a:lstStyle/>
+          <a:p>
+            <a:pPr algn="ctr">
+              <a:lnSpc>
+                <a:spcPct val="103000"/>
+              </a:lnSpc>
+              <a:spcBef>
+                <a:spcPts val="0"/>
+              </a:spcBef>
+              <a:spcAft>
+                <a:spcPts val="0"/>
+              </a:spcAft>
+            </a:pPr>
+            <a:r>
+              <a:rPr sz="1150" b="1">
+                <a:solidFill>
+                  <a:srgbClr val="F5862C"/>
+                </a:solidFill>
+                <a:latin typeface="Calibri"/>
+              </a:rPr>
+              <a:t>12%</a:t>
+            </a:r>
+            <a:r>
+              <a:rPr sz="1150" b="0">
+                <a:solidFill>
+                  <a:srgbClr val="718096"/>
+                </a:solidFill>
+                <a:latin typeface="Calibri"/>
+              </a:rPr>
+              <a:t>  /  </a:t>
+            </a:r>
+            <a:r>
+              <a:rPr sz="1150" b="1">
+                <a:solidFill>
+                  <a:srgbClr val="22C55E"/>
+                </a:solidFill>
+                <a:latin typeface="Calibri"/>
+              </a:rPr>
+              <a:t>8%</a:t>
+            </a:r>
+          </a:p>
+        </p:txBody>
+      </p:sp>
+      <p:sp>
+        <p:nvSpPr>
+          <p:cNvPr id="34" name="Rectangle 33"/>
+          <p:cNvSpPr/>
+          <p:nvPr/>
+        </p:nvSpPr>
+        <p:spPr>
+          <a:xfrm>
+            <a:off x="7818120" y="3200400"/>
+            <a:ext cx="2194560" cy="548640"/>
+          </a:xfrm>
+          <a:prstGeom prst="rect">
+            <a:avLst/>
+          </a:prstGeom>
+          <a:solidFill>
+            <a:srgbClr val="FFF6E9"/>
+          </a:solidFill>
+          <a:ln w="6350">
+            <a:solidFill>
+              <a:srgbClr val="E2E8F0"/>
+            </a:solidFill>
+          </a:ln>
+          <a:effectLst/>
+        </p:spPr>
+        <p:style>
+          <a:lnRef idx="1">
+            <a:schemeClr val="accent1"/>
+          </a:lnRef>
+          <a:fillRef idx="3">
+            <a:schemeClr val="accent1"/>
+          </a:fillRef>
+          <a:effectRef idx="2">
+            <a:schemeClr val="accent1"/>
+          </a:effectRef>
+          <a:fontRef idx="minor">
+            <a:schemeClr val="lt1"/>
+          </a:fontRef>
+        </p:style>
+        <p:txBody>
+          <a:bodyPr rtlCol="0" anchor="ctr"/>
+          <a:lstStyle/>
+          <a:p>
+            <a:pPr algn="ctr"/>
+          </a:p>
+        </p:txBody>
+      </p:sp>
+      <p:sp>
+        <p:nvSpPr>
+          <p:cNvPr id="35" name="TextBox 34"/>
+          <p:cNvSpPr txBox="1"/>
+          <p:nvPr/>
+        </p:nvSpPr>
+        <p:spPr>
+          <a:xfrm>
+            <a:off x="7818120" y="3200400"/>
+            <a:ext cx="2194560" cy="548640"/>
+          </a:xfrm>
+          <a:prstGeom prst="rect">
+            <a:avLst/>
+          </a:prstGeom>
+          <a:noFill/>
+        </p:spPr>
+        <p:txBody>
+          <a:bodyPr wrap="square" anchor="ctr" lIns="45720" rIns="45720" tIns="18288" bIns="9144">
+            <a:spAutoFit/>
+          </a:bodyPr>
+          <a:lstStyle/>
+          <a:p>
+            <a:pPr algn="ctr">
+              <a:lnSpc>
+                <a:spcPct val="103000"/>
+              </a:lnSpc>
+              <a:spcBef>
+                <a:spcPts val="0"/>
+              </a:spcBef>
+              <a:spcAft>
+                <a:spcPts val="0"/>
+              </a:spcAft>
+            </a:pPr>
+            <a:r>
+              <a:rPr sz="1150" b="1">
+                <a:solidFill>
+                  <a:srgbClr val="F5862C"/>
+                </a:solidFill>
+                <a:latin typeface="Calibri"/>
+              </a:rPr>
+              <a:t>10%</a:t>
+            </a:r>
+            <a:r>
+              <a:rPr sz="1150" b="0">
+                <a:solidFill>
+                  <a:srgbClr val="718096"/>
+                </a:solidFill>
+                <a:latin typeface="Calibri"/>
+              </a:rPr>
+              <a:t>  /  </a:t>
+            </a:r>
+            <a:r>
+              <a:rPr sz="1150" b="1">
+                <a:solidFill>
+                  <a:srgbClr val="22C55E"/>
+                </a:solidFill>
+                <a:latin typeface="Calibri"/>
+              </a:rPr>
+              <a:t>10%</a:t>
+            </a:r>
+          </a:p>
+        </p:txBody>
+      </p:sp>
+      <p:sp>
+        <p:nvSpPr>
+          <p:cNvPr id="36" name="Rectangle 35"/>
+          <p:cNvSpPr/>
+          <p:nvPr/>
+        </p:nvSpPr>
+        <p:spPr>
+          <a:xfrm>
+            <a:off x="411480" y="3749039"/>
+            <a:ext cx="3017520" cy="548640"/>
+          </a:xfrm>
+          <a:prstGeom prst="rect">
+            <a:avLst/>
+          </a:prstGeom>
+          <a:solidFill>
+            <a:srgbClr val="EAF0F8"/>
+          </a:solidFill>
+          <a:ln w="6350">
+            <a:solidFill>
+              <a:srgbClr val="E2E8F0"/>
+            </a:solidFill>
+          </a:ln>
+          <a:effectLst/>
+        </p:spPr>
+        <p:style>
+          <a:lnRef idx="1">
+            <a:schemeClr val="accent1"/>
+          </a:lnRef>
+          <a:fillRef idx="3">
+            <a:schemeClr val="accent1"/>
+          </a:fillRef>
+          <a:effectRef idx="2">
+            <a:schemeClr val="accent1"/>
+          </a:effectRef>
+          <a:fontRef idx="minor">
+            <a:schemeClr val="lt1"/>
+          </a:fontRef>
+        </p:style>
+        <p:txBody>
+          <a:bodyPr rtlCol="0" anchor="ctr"/>
+          <a:lstStyle/>
+          <a:p>
+            <a:pPr algn="ctr"/>
+          </a:p>
+        </p:txBody>
+      </p:sp>
+      <p:sp>
+        <p:nvSpPr>
+          <p:cNvPr id="37" name="TextBox 36"/>
+          <p:cNvSpPr txBox="1"/>
+          <p:nvPr/>
+        </p:nvSpPr>
+        <p:spPr>
+          <a:xfrm>
+            <a:off x="411480" y="3749039"/>
+            <a:ext cx="3017520" cy="548640"/>
+          </a:xfrm>
+          <a:prstGeom prst="rect">
+            <a:avLst/>
+          </a:prstGeom>
+          <a:noFill/>
+        </p:spPr>
+        <p:txBody>
+          <a:bodyPr wrap="square" anchor="ctr" lIns="45720" rIns="45720" tIns="18288" bIns="9144">
+            <a:spAutoFit/>
+          </a:bodyPr>
+          <a:lstStyle/>
+          <a:p>
+            <a:pPr algn="ctr">
+              <a:lnSpc>
+                <a:spcPct val="103000"/>
+              </a:lnSpc>
+              <a:spcBef>
+                <a:spcPts val="0"/>
+              </a:spcBef>
+              <a:spcAft>
+                <a:spcPts val="0"/>
+              </a:spcAft>
+            </a:pPr>
+            <a:r>
+              <a:rPr sz="950" b="1">
+                <a:solidFill>
+                  <a:srgbClr val="001A40"/>
+                </a:solidFill>
+                <a:latin typeface="Calibri"/>
+              </a:rPr>
+              <a:t>100–299  (GAPIT −15%)</a:t>
+            </a:r>
+          </a:p>
+        </p:txBody>
+      </p:sp>
+      <p:sp>
+        <p:nvSpPr>
+          <p:cNvPr id="38" name="Rectangle 37"/>
+          <p:cNvSpPr/>
+          <p:nvPr/>
+        </p:nvSpPr>
+        <p:spPr>
+          <a:xfrm>
+            <a:off x="3429000" y="3749039"/>
+            <a:ext cx="2194560" cy="548640"/>
           </a:xfrm>
           <a:prstGeom prst="rect">
             <a:avLst/>
@@ -5771,14 +6632,14 @@
       </p:sp>
       <p:sp>
         <p:nvSpPr>
-          <p:cNvPr id="22" name="TextBox 21"/>
+          <p:cNvPr id="39" name="TextBox 38"/>
           <p:cNvSpPr txBox="1"/>
           <p:nvPr/>
         </p:nvSpPr>
         <p:spPr>
           <a:xfrm>
-            <a:off x="411480" y="2084832"/>
-            <a:ext cx="1874519" cy="457200"/>
+            <a:off x="3429000" y="3749039"/>
+            <a:ext cx="2194560" cy="548640"/>
           </a:xfrm>
           <a:prstGeom prst="rect">
             <a:avLst/>
@@ -5803,27 +6664,45 @@
               </a:spcAft>
             </a:pPr>
             <a:r>
-              <a:rPr sz="1100" b="1">
-                <a:solidFill>
-                  <a:srgbClr val="001A40"/>
-                </a:solidFill>
-                <a:latin typeface="Calibri"/>
-              </a:rPr>
-              <a:t>50 – 99</a:t>
-            </a:r>
-          </a:p>
-        </p:txBody>
-      </p:sp>
-      <p:sp>
-        <p:nvSpPr>
-          <p:cNvPr id="23" name="Rectangle 22"/>
+              <a:rPr sz="1150" b="1">
+                <a:solidFill>
+                  <a:srgbClr val="F5862C"/>
+                </a:solidFill>
+                <a:latin typeface="Calibri"/>
+              </a:rPr>
+              <a:t>10%</a:t>
+            </a:r>
+            <a:r>
+              <a:rPr sz="1150" b="0">
+                <a:solidFill>
+                  <a:srgbClr val="718096"/>
+                </a:solidFill>
+                <a:latin typeface="Calibri"/>
+              </a:rPr>
+              <a:t>  /  </a:t>
+            </a:r>
+            <a:r>
+              <a:rPr sz="1150" b="1">
+                <a:solidFill>
+                  <a:srgbClr val="22C55E"/>
+                </a:solidFill>
+                <a:latin typeface="Calibri"/>
+              </a:rPr>
+              <a:t>5%</a:t>
+            </a:r>
+          </a:p>
+        </p:txBody>
+      </p:sp>
+      <p:sp>
+        <p:nvSpPr>
+          <p:cNvPr id="40" name="Rectangle 39"/>
           <p:cNvSpPr/>
           <p:nvPr/>
         </p:nvSpPr>
         <p:spPr>
           <a:xfrm>
-            <a:off x="2286000" y="2084832"/>
-            <a:ext cx="1691640" cy="457200"/>
+            <a:off x="5623560" y="3749039"/>
+            <a:ext cx="2194560" cy="548640"/>
           </a:xfrm>
           <a:prstGeom prst="rect">
             <a:avLst/>
@@ -5862,14 +6741,14 @@
       </p:sp>
       <p:sp>
         <p:nvSpPr>
-          <p:cNvPr id="24" name="TextBox 23"/>
+          <p:cNvPr id="41" name="TextBox 40"/>
           <p:cNvSpPr txBox="1"/>
           <p:nvPr/>
         </p:nvSpPr>
         <p:spPr>
           <a:xfrm>
-            <a:off x="2286000" y="2084832"/>
-            <a:ext cx="1691640" cy="457200"/>
+            <a:off x="5623560" y="3749039"/>
+            <a:ext cx="2194560" cy="548640"/>
           </a:xfrm>
           <a:prstGeom prst="rect">
             <a:avLst/>
@@ -5894,27 +6773,45 @@
               </a:spcAft>
             </a:pPr>
             <a:r>
-              <a:rPr sz="1100" b="0">
-                <a:solidFill>
-                  <a:srgbClr val="4A5568"/>
-                </a:solidFill>
-                <a:latin typeface="Calibri"/>
-              </a:rPr>
-              <a:t>5%</a:t>
-            </a:r>
-          </a:p>
-        </p:txBody>
-      </p:sp>
-      <p:sp>
-        <p:nvSpPr>
-          <p:cNvPr id="25" name="Rectangle 24"/>
+              <a:rPr sz="1150" b="1">
+                <a:solidFill>
+                  <a:srgbClr val="F5862C"/>
+                </a:solidFill>
+                <a:latin typeface="Calibri"/>
+              </a:rPr>
+              <a:t>7%</a:t>
+            </a:r>
+            <a:r>
+              <a:rPr sz="1150" b="0">
+                <a:solidFill>
+                  <a:srgbClr val="718096"/>
+                </a:solidFill>
+                <a:latin typeface="Calibri"/>
+              </a:rPr>
+              <a:t>  /  </a:t>
+            </a:r>
+            <a:r>
+              <a:rPr sz="1150" b="1">
+                <a:solidFill>
+                  <a:srgbClr val="22C55E"/>
+                </a:solidFill>
+                <a:latin typeface="Calibri"/>
+              </a:rPr>
+              <a:t>8%</a:t>
+            </a:r>
+          </a:p>
+        </p:txBody>
+      </p:sp>
+      <p:sp>
+        <p:nvSpPr>
+          <p:cNvPr id="42" name="Rectangle 41"/>
           <p:cNvSpPr/>
           <p:nvPr/>
         </p:nvSpPr>
         <p:spPr>
           <a:xfrm>
-            <a:off x="3977639" y="2084832"/>
-            <a:ext cx="1554480" cy="457200"/>
+            <a:off x="7818120" y="3749039"/>
+            <a:ext cx="2194560" cy="548640"/>
           </a:xfrm>
           <a:prstGeom prst="rect">
             <a:avLst/>
@@ -5953,14 +6850,14 @@
       </p:sp>
       <p:sp>
         <p:nvSpPr>
-          <p:cNvPr id="26" name="TextBox 25"/>
+          <p:cNvPr id="43" name="TextBox 42"/>
           <p:cNvSpPr txBox="1"/>
           <p:nvPr/>
         </p:nvSpPr>
         <p:spPr>
           <a:xfrm>
-            <a:off x="3977639" y="2084832"/>
-            <a:ext cx="1554480" cy="457200"/>
+            <a:off x="7818120" y="3749039"/>
+            <a:ext cx="2194560" cy="548640"/>
           </a:xfrm>
           <a:prstGeom prst="rect">
             <a:avLst/>
@@ -5985,788 +6882,32 @@
               </a:spcAft>
             </a:pPr>
             <a:r>
-              <a:rPr sz="1100" b="0">
-                <a:solidFill>
-                  <a:srgbClr val="4A5568"/>
+              <a:rPr sz="1150" b="1">
+                <a:solidFill>
+                  <a:srgbClr val="F5862C"/>
                 </a:solidFill>
                 <a:latin typeface="Calibri"/>
               </a:rPr>
               <a:t>5%</a:t>
             </a:r>
-          </a:p>
-        </p:txBody>
-      </p:sp>
-      <p:sp>
-        <p:nvSpPr>
-          <p:cNvPr id="27" name="Rectangle 26"/>
-          <p:cNvSpPr/>
-          <p:nvPr/>
-        </p:nvSpPr>
-        <p:spPr>
-          <a:xfrm>
-            <a:off x="5532120" y="2084832"/>
-            <a:ext cx="1783080" cy="457200"/>
-          </a:xfrm>
-          <a:prstGeom prst="rect">
-            <a:avLst/>
-          </a:prstGeom>
-          <a:solidFill>
-            <a:srgbClr val="FFF1E6"/>
-          </a:solidFill>
-          <a:ln w="6350">
-            <a:solidFill>
-              <a:srgbClr val="E2E8F0"/>
-            </a:solidFill>
-          </a:ln>
-          <a:effectLst/>
-        </p:spPr>
-        <p:style>
-          <a:lnRef idx="1">
-            <a:schemeClr val="accent1"/>
-          </a:lnRef>
-          <a:fillRef idx="3">
-            <a:schemeClr val="accent1"/>
-          </a:fillRef>
-          <a:effectRef idx="2">
-            <a:schemeClr val="accent1"/>
-          </a:effectRef>
-          <a:fontRef idx="minor">
-            <a:schemeClr val="lt1"/>
-          </a:fontRef>
-        </p:style>
-        <p:txBody>
-          <a:bodyPr rtlCol="0" anchor="ctr"/>
-          <a:lstStyle/>
-          <a:p>
-            <a:pPr algn="ctr"/>
-          </a:p>
-        </p:txBody>
-      </p:sp>
-      <p:sp>
-        <p:nvSpPr>
-          <p:cNvPr id="28" name="TextBox 27"/>
-          <p:cNvSpPr txBox="1"/>
-          <p:nvPr/>
-        </p:nvSpPr>
-        <p:spPr>
-          <a:xfrm>
-            <a:off x="5532120" y="2084832"/>
-            <a:ext cx="1783080" cy="457200"/>
-          </a:xfrm>
-          <a:prstGeom prst="rect">
-            <a:avLst/>
-          </a:prstGeom>
-          <a:noFill/>
-        </p:spPr>
-        <p:txBody>
-          <a:bodyPr wrap="square" anchor="ctr" lIns="45720" rIns="45720" tIns="18288" bIns="9144">
-            <a:spAutoFit/>
-          </a:bodyPr>
-          <a:lstStyle/>
-          <a:p>
-            <a:pPr algn="ctr">
-              <a:lnSpc>
-                <a:spcPct val="103000"/>
-              </a:lnSpc>
-              <a:spcBef>
-                <a:spcPts val="0"/>
-              </a:spcBef>
-              <a:spcAft>
-                <a:spcPts val="0"/>
-              </a:spcAft>
-            </a:pPr>
-            <a:r>
-              <a:rPr sz="1100" b="1">
-                <a:solidFill>
-                  <a:srgbClr val="F5862C"/>
-                </a:solidFill>
-                <a:latin typeface="Calibri"/>
-              </a:rPr>
-              <a:t>15%</a:t>
-            </a:r>
-          </a:p>
-        </p:txBody>
-      </p:sp>
-      <p:sp>
-        <p:nvSpPr>
-          <p:cNvPr id="29" name="Rectangle 28"/>
-          <p:cNvSpPr/>
-          <p:nvPr/>
-        </p:nvSpPr>
-        <p:spPr>
-          <a:xfrm>
-            <a:off x="7315200" y="2084832"/>
-            <a:ext cx="1234440" cy="457200"/>
-          </a:xfrm>
-          <a:prstGeom prst="rect">
-            <a:avLst/>
-          </a:prstGeom>
-          <a:solidFill>
-            <a:srgbClr val="FFFFFF"/>
-          </a:solidFill>
-          <a:ln w="6350">
-            <a:solidFill>
-              <a:srgbClr val="E2E8F0"/>
-            </a:solidFill>
-          </a:ln>
-          <a:effectLst/>
-        </p:spPr>
-        <p:style>
-          <a:lnRef idx="1">
-            <a:schemeClr val="accent1"/>
-          </a:lnRef>
-          <a:fillRef idx="3">
-            <a:schemeClr val="accent1"/>
-          </a:fillRef>
-          <a:effectRef idx="2">
-            <a:schemeClr val="accent1"/>
-          </a:effectRef>
-          <a:fontRef idx="minor">
-            <a:schemeClr val="lt1"/>
-          </a:fontRef>
-        </p:style>
-        <p:txBody>
-          <a:bodyPr rtlCol="0" anchor="ctr"/>
-          <a:lstStyle/>
-          <a:p>
-            <a:pPr algn="ctr"/>
-          </a:p>
-        </p:txBody>
-      </p:sp>
-      <p:sp>
-        <p:nvSpPr>
-          <p:cNvPr id="30" name="TextBox 29"/>
-          <p:cNvSpPr txBox="1"/>
-          <p:nvPr/>
-        </p:nvSpPr>
-        <p:spPr>
-          <a:xfrm>
-            <a:off x="7315200" y="2084832"/>
-            <a:ext cx="1234440" cy="457200"/>
-          </a:xfrm>
-          <a:prstGeom prst="rect">
-            <a:avLst/>
-          </a:prstGeom>
-          <a:noFill/>
-        </p:spPr>
-        <p:txBody>
-          <a:bodyPr wrap="square" anchor="ctr" lIns="45720" rIns="45720" tIns="18288" bIns="9144">
-            <a:spAutoFit/>
-          </a:bodyPr>
-          <a:lstStyle/>
-          <a:p>
-            <a:pPr algn="ctr">
-              <a:lnSpc>
-                <a:spcPct val="103000"/>
-              </a:lnSpc>
-              <a:spcBef>
-                <a:spcPts val="0"/>
-              </a:spcBef>
-              <a:spcAft>
-                <a:spcPts val="0"/>
-              </a:spcAft>
-            </a:pPr>
-            <a:r>
-              <a:rPr sz="1100" b="0">
-                <a:solidFill>
-                  <a:srgbClr val="4A5568"/>
-                </a:solidFill>
-                <a:latin typeface="Calibri"/>
-              </a:rPr>
-              <a:t>20%</a:t>
-            </a:r>
-          </a:p>
-        </p:txBody>
-      </p:sp>
-      <p:sp>
-        <p:nvSpPr>
-          <p:cNvPr id="31" name="Rectangle 30"/>
-          <p:cNvSpPr/>
-          <p:nvPr/>
-        </p:nvSpPr>
-        <p:spPr>
-          <a:xfrm>
-            <a:off x="411480" y="2542032"/>
-            <a:ext cx="1874519" cy="457200"/>
-          </a:xfrm>
-          <a:prstGeom prst="rect">
-            <a:avLst/>
-          </a:prstGeom>
-          <a:solidFill>
-            <a:srgbClr val="F4F7FB"/>
-          </a:solidFill>
-          <a:ln w="6350">
-            <a:solidFill>
-              <a:srgbClr val="E2E8F0"/>
-            </a:solidFill>
-          </a:ln>
-          <a:effectLst/>
-        </p:spPr>
-        <p:style>
-          <a:lnRef idx="1">
-            <a:schemeClr val="accent1"/>
-          </a:lnRef>
-          <a:fillRef idx="3">
-            <a:schemeClr val="accent1"/>
-          </a:fillRef>
-          <a:effectRef idx="2">
-            <a:schemeClr val="accent1"/>
-          </a:effectRef>
-          <a:fontRef idx="minor">
-            <a:schemeClr val="lt1"/>
-          </a:fontRef>
-        </p:style>
-        <p:txBody>
-          <a:bodyPr rtlCol="0" anchor="ctr"/>
-          <a:lstStyle/>
-          <a:p>
-            <a:pPr algn="ctr"/>
-          </a:p>
-        </p:txBody>
-      </p:sp>
-      <p:sp>
-        <p:nvSpPr>
-          <p:cNvPr id="32" name="TextBox 31"/>
-          <p:cNvSpPr txBox="1"/>
-          <p:nvPr/>
-        </p:nvSpPr>
-        <p:spPr>
-          <a:xfrm>
-            <a:off x="411480" y="2542032"/>
-            <a:ext cx="1874519" cy="457200"/>
-          </a:xfrm>
-          <a:prstGeom prst="rect">
-            <a:avLst/>
-          </a:prstGeom>
-          <a:noFill/>
-        </p:spPr>
-        <p:txBody>
-          <a:bodyPr wrap="square" anchor="ctr" lIns="45720" rIns="45720" tIns="18288" bIns="9144">
-            <a:spAutoFit/>
-          </a:bodyPr>
-          <a:lstStyle/>
-          <a:p>
-            <a:pPr algn="ctr">
-              <a:lnSpc>
-                <a:spcPct val="103000"/>
-              </a:lnSpc>
-              <a:spcBef>
-                <a:spcPts val="0"/>
-              </a:spcBef>
-              <a:spcAft>
-                <a:spcPts val="0"/>
-              </a:spcAft>
-            </a:pPr>
-            <a:r>
-              <a:rPr sz="1100" b="1">
-                <a:solidFill>
-                  <a:srgbClr val="001A40"/>
-                </a:solidFill>
-                <a:latin typeface="Calibri"/>
-              </a:rPr>
-              <a:t>100 – 299</a:t>
-            </a:r>
-          </a:p>
-        </p:txBody>
-      </p:sp>
-      <p:sp>
-        <p:nvSpPr>
-          <p:cNvPr id="33" name="Rectangle 32"/>
-          <p:cNvSpPr/>
-          <p:nvPr/>
-        </p:nvSpPr>
-        <p:spPr>
-          <a:xfrm>
-            <a:off x="2286000" y="2542032"/>
-            <a:ext cx="1691640" cy="457200"/>
-          </a:xfrm>
-          <a:prstGeom prst="rect">
-            <a:avLst/>
-          </a:prstGeom>
-          <a:solidFill>
-            <a:srgbClr val="F4F7FB"/>
-          </a:solidFill>
-          <a:ln w="6350">
-            <a:solidFill>
-              <a:srgbClr val="E2E8F0"/>
-            </a:solidFill>
-          </a:ln>
-          <a:effectLst/>
-        </p:spPr>
-        <p:style>
-          <a:lnRef idx="1">
-            <a:schemeClr val="accent1"/>
-          </a:lnRef>
-          <a:fillRef idx="3">
-            <a:schemeClr val="accent1"/>
-          </a:fillRef>
-          <a:effectRef idx="2">
-            <a:schemeClr val="accent1"/>
-          </a:effectRef>
-          <a:fontRef idx="minor">
-            <a:schemeClr val="lt1"/>
-          </a:fontRef>
-        </p:style>
-        <p:txBody>
-          <a:bodyPr rtlCol="0" anchor="ctr"/>
-          <a:lstStyle/>
-          <a:p>
-            <a:pPr algn="ctr"/>
-          </a:p>
-        </p:txBody>
-      </p:sp>
-      <p:sp>
-        <p:nvSpPr>
-          <p:cNvPr id="34" name="TextBox 33"/>
-          <p:cNvSpPr txBox="1"/>
-          <p:nvPr/>
-        </p:nvSpPr>
-        <p:spPr>
-          <a:xfrm>
-            <a:off x="2286000" y="2542032"/>
-            <a:ext cx="1691640" cy="457200"/>
-          </a:xfrm>
-          <a:prstGeom prst="rect">
-            <a:avLst/>
-          </a:prstGeom>
-          <a:noFill/>
-        </p:spPr>
-        <p:txBody>
-          <a:bodyPr wrap="square" anchor="ctr" lIns="45720" rIns="45720" tIns="18288" bIns="9144">
-            <a:spAutoFit/>
-          </a:bodyPr>
-          <a:lstStyle/>
-          <a:p>
-            <a:pPr algn="ctr">
-              <a:lnSpc>
-                <a:spcPct val="103000"/>
-              </a:lnSpc>
-              <a:spcBef>
-                <a:spcPts val="0"/>
-              </a:spcBef>
-              <a:spcAft>
-                <a:spcPts val="0"/>
-              </a:spcAft>
-            </a:pPr>
-            <a:r>
-              <a:rPr sz="1100" b="0">
-                <a:solidFill>
-                  <a:srgbClr val="4A5568"/>
-                </a:solidFill>
-                <a:latin typeface="Calibri"/>
-              </a:rPr>
-              <a:t>8%</a:t>
-            </a:r>
-          </a:p>
-        </p:txBody>
-      </p:sp>
-      <p:sp>
-        <p:nvSpPr>
-          <p:cNvPr id="35" name="Rectangle 34"/>
-          <p:cNvSpPr/>
-          <p:nvPr/>
-        </p:nvSpPr>
-        <p:spPr>
-          <a:xfrm>
-            <a:off x="3977639" y="2542032"/>
-            <a:ext cx="1554480" cy="457200"/>
-          </a:xfrm>
-          <a:prstGeom prst="rect">
-            <a:avLst/>
-          </a:prstGeom>
-          <a:solidFill>
-            <a:srgbClr val="F4F7FB"/>
-          </a:solidFill>
-          <a:ln w="6350">
-            <a:solidFill>
-              <a:srgbClr val="E2E8F0"/>
-            </a:solidFill>
-          </a:ln>
-          <a:effectLst/>
-        </p:spPr>
-        <p:style>
-          <a:lnRef idx="1">
-            <a:schemeClr val="accent1"/>
-          </a:lnRef>
-          <a:fillRef idx="3">
-            <a:schemeClr val="accent1"/>
-          </a:fillRef>
-          <a:effectRef idx="2">
-            <a:schemeClr val="accent1"/>
-          </a:effectRef>
-          <a:fontRef idx="minor">
-            <a:schemeClr val="lt1"/>
-          </a:fontRef>
-        </p:style>
-        <p:txBody>
-          <a:bodyPr rtlCol="0" anchor="ctr"/>
-          <a:lstStyle/>
-          <a:p>
-            <a:pPr algn="ctr"/>
-          </a:p>
-        </p:txBody>
-      </p:sp>
-      <p:sp>
-        <p:nvSpPr>
-          <p:cNvPr id="36" name="TextBox 35"/>
-          <p:cNvSpPr txBox="1"/>
-          <p:nvPr/>
-        </p:nvSpPr>
-        <p:spPr>
-          <a:xfrm>
-            <a:off x="3977639" y="2542032"/>
-            <a:ext cx="1554480" cy="457200"/>
-          </a:xfrm>
-          <a:prstGeom prst="rect">
-            <a:avLst/>
-          </a:prstGeom>
-          <a:noFill/>
-        </p:spPr>
-        <p:txBody>
-          <a:bodyPr wrap="square" anchor="ctr" lIns="45720" rIns="45720" tIns="18288" bIns="9144">
-            <a:spAutoFit/>
-          </a:bodyPr>
-          <a:lstStyle/>
-          <a:p>
-            <a:pPr algn="ctr">
-              <a:lnSpc>
-                <a:spcPct val="103000"/>
-              </a:lnSpc>
-              <a:spcBef>
-                <a:spcPts val="0"/>
-              </a:spcBef>
-              <a:spcAft>
-                <a:spcPts val="0"/>
-              </a:spcAft>
-            </a:pPr>
-            <a:r>
-              <a:rPr sz="1100" b="0">
-                <a:solidFill>
-                  <a:srgbClr val="4A5568"/>
-                </a:solidFill>
-                <a:latin typeface="Calibri"/>
-              </a:rPr>
-              <a:t>8%</a:t>
-            </a:r>
-          </a:p>
-        </p:txBody>
-      </p:sp>
-      <p:sp>
-        <p:nvSpPr>
-          <p:cNvPr id="37" name="Rectangle 36"/>
-          <p:cNvSpPr/>
-          <p:nvPr/>
-        </p:nvSpPr>
-        <p:spPr>
-          <a:xfrm>
-            <a:off x="5532120" y="2542032"/>
-            <a:ext cx="1783080" cy="457200"/>
-          </a:xfrm>
-          <a:prstGeom prst="rect">
-            <a:avLst/>
-          </a:prstGeom>
-          <a:solidFill>
-            <a:srgbClr val="FFF1E6"/>
-          </a:solidFill>
-          <a:ln w="6350">
-            <a:solidFill>
-              <a:srgbClr val="E2E8F0"/>
-            </a:solidFill>
-          </a:ln>
-          <a:effectLst/>
-        </p:spPr>
-        <p:style>
-          <a:lnRef idx="1">
-            <a:schemeClr val="accent1"/>
-          </a:lnRef>
-          <a:fillRef idx="3">
-            <a:schemeClr val="accent1"/>
-          </a:fillRef>
-          <a:effectRef idx="2">
-            <a:schemeClr val="accent1"/>
-          </a:effectRef>
-          <a:fontRef idx="minor">
-            <a:schemeClr val="lt1"/>
-          </a:fontRef>
-        </p:style>
-        <p:txBody>
-          <a:bodyPr rtlCol="0" anchor="ctr"/>
-          <a:lstStyle/>
-          <a:p>
-            <a:pPr algn="ctr"/>
-          </a:p>
-        </p:txBody>
-      </p:sp>
-      <p:sp>
-        <p:nvSpPr>
-          <p:cNvPr id="38" name="TextBox 37"/>
-          <p:cNvSpPr txBox="1"/>
-          <p:nvPr/>
-        </p:nvSpPr>
-        <p:spPr>
-          <a:xfrm>
-            <a:off x="5532120" y="2542032"/>
-            <a:ext cx="1783080" cy="457200"/>
-          </a:xfrm>
-          <a:prstGeom prst="rect">
-            <a:avLst/>
-          </a:prstGeom>
-          <a:noFill/>
-        </p:spPr>
-        <p:txBody>
-          <a:bodyPr wrap="square" anchor="ctr" lIns="45720" rIns="45720" tIns="18288" bIns="9144">
-            <a:spAutoFit/>
-          </a:bodyPr>
-          <a:lstStyle/>
-          <a:p>
-            <a:pPr algn="ctr">
-              <a:lnSpc>
-                <a:spcPct val="103000"/>
-              </a:lnSpc>
-              <a:spcBef>
-                <a:spcPts val="0"/>
-              </a:spcBef>
-              <a:spcAft>
-                <a:spcPts val="0"/>
-              </a:spcAft>
-            </a:pPr>
-            <a:r>
-              <a:rPr sz="1100" b="1">
-                <a:solidFill>
-                  <a:srgbClr val="F5862C"/>
-                </a:solidFill>
-                <a:latin typeface="Calibri"/>
-              </a:rPr>
-              <a:t>12%</a:t>
-            </a:r>
-          </a:p>
-        </p:txBody>
-      </p:sp>
-      <p:sp>
-        <p:nvSpPr>
-          <p:cNvPr id="39" name="Rectangle 38"/>
-          <p:cNvSpPr/>
-          <p:nvPr/>
-        </p:nvSpPr>
-        <p:spPr>
-          <a:xfrm>
-            <a:off x="7315200" y="2542032"/>
-            <a:ext cx="1234440" cy="457200"/>
-          </a:xfrm>
-          <a:prstGeom prst="rect">
-            <a:avLst/>
-          </a:prstGeom>
-          <a:solidFill>
-            <a:srgbClr val="F4F7FB"/>
-          </a:solidFill>
-          <a:ln w="6350">
-            <a:solidFill>
-              <a:srgbClr val="E2E8F0"/>
-            </a:solidFill>
-          </a:ln>
-          <a:effectLst/>
-        </p:spPr>
-        <p:style>
-          <a:lnRef idx="1">
-            <a:schemeClr val="accent1"/>
-          </a:lnRef>
-          <a:fillRef idx="3">
-            <a:schemeClr val="accent1"/>
-          </a:fillRef>
-          <a:effectRef idx="2">
-            <a:schemeClr val="accent1"/>
-          </a:effectRef>
-          <a:fontRef idx="minor">
-            <a:schemeClr val="lt1"/>
-          </a:fontRef>
-        </p:style>
-        <p:txBody>
-          <a:bodyPr rtlCol="0" anchor="ctr"/>
-          <a:lstStyle/>
-          <a:p>
-            <a:pPr algn="ctr"/>
-          </a:p>
-        </p:txBody>
-      </p:sp>
-      <p:sp>
-        <p:nvSpPr>
-          <p:cNvPr id="40" name="TextBox 39"/>
-          <p:cNvSpPr txBox="1"/>
-          <p:nvPr/>
-        </p:nvSpPr>
-        <p:spPr>
-          <a:xfrm>
-            <a:off x="7315200" y="2542032"/>
-            <a:ext cx="1234440" cy="457200"/>
-          </a:xfrm>
-          <a:prstGeom prst="rect">
-            <a:avLst/>
-          </a:prstGeom>
-          <a:noFill/>
-        </p:spPr>
-        <p:txBody>
-          <a:bodyPr wrap="square" anchor="ctr" lIns="45720" rIns="45720" tIns="18288" bIns="9144">
-            <a:spAutoFit/>
-          </a:bodyPr>
-          <a:lstStyle/>
-          <a:p>
-            <a:pPr algn="ctr">
-              <a:lnSpc>
-                <a:spcPct val="103000"/>
-              </a:lnSpc>
-              <a:spcBef>
-                <a:spcPts val="0"/>
-              </a:spcBef>
-              <a:spcAft>
-                <a:spcPts val="0"/>
-              </a:spcAft>
-            </a:pPr>
-            <a:r>
-              <a:rPr sz="1100" b="0">
-                <a:solidFill>
-                  <a:srgbClr val="4A5568"/>
-                </a:solidFill>
-                <a:latin typeface="Calibri"/>
-              </a:rPr>
-              <a:t>20%</a:t>
-            </a:r>
-          </a:p>
-        </p:txBody>
-      </p:sp>
-      <p:sp>
-        <p:nvSpPr>
-          <p:cNvPr id="41" name="Rectangle 40"/>
-          <p:cNvSpPr/>
-          <p:nvPr/>
-        </p:nvSpPr>
-        <p:spPr>
-          <a:xfrm>
-            <a:off x="411480" y="2999232"/>
-            <a:ext cx="1874519" cy="457200"/>
-          </a:xfrm>
-          <a:prstGeom prst="rect">
-            <a:avLst/>
-          </a:prstGeom>
-          <a:solidFill>
-            <a:srgbClr val="FFFFFF"/>
-          </a:solidFill>
-          <a:ln w="6350">
-            <a:solidFill>
-              <a:srgbClr val="E2E8F0"/>
-            </a:solidFill>
-          </a:ln>
-          <a:effectLst/>
-        </p:spPr>
-        <p:style>
-          <a:lnRef idx="1">
-            <a:schemeClr val="accent1"/>
-          </a:lnRef>
-          <a:fillRef idx="3">
-            <a:schemeClr val="accent1"/>
-          </a:fillRef>
-          <a:effectRef idx="2">
-            <a:schemeClr val="accent1"/>
-          </a:effectRef>
-          <a:fontRef idx="minor">
-            <a:schemeClr val="lt1"/>
-          </a:fontRef>
-        </p:style>
-        <p:txBody>
-          <a:bodyPr rtlCol="0" anchor="ctr"/>
-          <a:lstStyle/>
-          <a:p>
-            <a:pPr algn="ctr"/>
-          </a:p>
-        </p:txBody>
-      </p:sp>
-      <p:sp>
-        <p:nvSpPr>
-          <p:cNvPr id="42" name="TextBox 41"/>
-          <p:cNvSpPr txBox="1"/>
-          <p:nvPr/>
-        </p:nvSpPr>
-        <p:spPr>
-          <a:xfrm>
-            <a:off x="411480" y="2999232"/>
-            <a:ext cx="1874519" cy="457200"/>
-          </a:xfrm>
-          <a:prstGeom prst="rect">
-            <a:avLst/>
-          </a:prstGeom>
-          <a:noFill/>
-        </p:spPr>
-        <p:txBody>
-          <a:bodyPr wrap="square" anchor="ctr" lIns="45720" rIns="45720" tIns="18288" bIns="9144">
-            <a:spAutoFit/>
-          </a:bodyPr>
-          <a:lstStyle/>
-          <a:p>
-            <a:pPr algn="ctr">
-              <a:lnSpc>
-                <a:spcPct val="103000"/>
-              </a:lnSpc>
-              <a:spcBef>
-                <a:spcPts val="0"/>
-              </a:spcBef>
-              <a:spcAft>
-                <a:spcPts val="0"/>
-              </a:spcAft>
-            </a:pPr>
-            <a:r>
-              <a:rPr sz="1100" b="1">
-                <a:solidFill>
-                  <a:srgbClr val="001A40"/>
-                </a:solidFill>
-                <a:latin typeface="Calibri"/>
-              </a:rPr>
-              <a:t>≥ 300</a:t>
-            </a:r>
-          </a:p>
-        </p:txBody>
-      </p:sp>
-      <p:sp>
-        <p:nvSpPr>
-          <p:cNvPr id="43" name="Rectangle 42"/>
-          <p:cNvSpPr/>
-          <p:nvPr/>
-        </p:nvSpPr>
-        <p:spPr>
-          <a:xfrm>
-            <a:off x="2286000" y="2999232"/>
-            <a:ext cx="1691640" cy="457200"/>
-          </a:xfrm>
-          <a:prstGeom prst="rect">
-            <a:avLst/>
-          </a:prstGeom>
-          <a:solidFill>
-            <a:srgbClr val="FFFFFF"/>
-          </a:solidFill>
-          <a:ln w="6350">
-            <a:solidFill>
-              <a:srgbClr val="E2E8F0"/>
-            </a:solidFill>
-          </a:ln>
-          <a:effectLst/>
-        </p:spPr>
-        <p:style>
-          <a:lnRef idx="1">
-            <a:schemeClr val="accent1"/>
-          </a:lnRef>
-          <a:fillRef idx="3">
-            <a:schemeClr val="accent1"/>
-          </a:fillRef>
-          <a:effectRef idx="2">
-            <a:schemeClr val="accent1"/>
-          </a:effectRef>
-          <a:fontRef idx="minor">
-            <a:schemeClr val="lt1"/>
-          </a:fontRef>
-        </p:style>
-        <p:txBody>
-          <a:bodyPr rtlCol="0" anchor="ctr"/>
-          <a:lstStyle/>
-          <a:p>
-            <a:pPr algn="ctr"/>
+            <a:r>
+              <a:rPr sz="1150" b="0">
+                <a:solidFill>
+                  <a:srgbClr val="718096"/>
+                </a:solidFill>
+                <a:latin typeface="Calibri"/>
+              </a:rPr>
+              <a:t>  /  </a:t>
+            </a:r>
+            <a:r>
+              <a:rPr sz="1150" b="1">
+                <a:solidFill>
+                  <a:srgbClr val="22C55E"/>
+                </a:solidFill>
+                <a:latin typeface="Calibri"/>
+              </a:rPr>
+              <a:t>10%</a:t>
+            </a:r>
           </a:p>
         </p:txBody>
       </p:sp>
@@ -6778,326 +6919,8 @@
         </p:nvSpPr>
         <p:spPr>
           <a:xfrm>
-            <a:off x="2286000" y="2999232"/>
-            <a:ext cx="1691640" cy="457200"/>
-          </a:xfrm>
-          <a:prstGeom prst="rect">
-            <a:avLst/>
-          </a:prstGeom>
-          <a:noFill/>
-        </p:spPr>
-        <p:txBody>
-          <a:bodyPr wrap="square" anchor="ctr" lIns="45720" rIns="45720" tIns="18288" bIns="9144">
-            <a:spAutoFit/>
-          </a:bodyPr>
-          <a:lstStyle/>
-          <a:p>
-            <a:pPr algn="ctr">
-              <a:lnSpc>
-                <a:spcPct val="103000"/>
-              </a:lnSpc>
-              <a:spcBef>
-                <a:spcPts val="0"/>
-              </a:spcBef>
-              <a:spcAft>
-                <a:spcPts val="0"/>
-              </a:spcAft>
-            </a:pPr>
-            <a:r>
-              <a:rPr sz="1100" b="0">
-                <a:solidFill>
-                  <a:srgbClr val="4A5568"/>
-                </a:solidFill>
-                <a:latin typeface="Calibri"/>
-              </a:rPr>
-              <a:t>10%</a:t>
-            </a:r>
-          </a:p>
-        </p:txBody>
-      </p:sp>
-      <p:sp>
-        <p:nvSpPr>
-          <p:cNvPr id="45" name="Rectangle 44"/>
-          <p:cNvSpPr/>
-          <p:nvPr/>
-        </p:nvSpPr>
-        <p:spPr>
-          <a:xfrm>
-            <a:off x="3977639" y="2999232"/>
-            <a:ext cx="1554480" cy="457200"/>
-          </a:xfrm>
-          <a:prstGeom prst="rect">
-            <a:avLst/>
-          </a:prstGeom>
-          <a:solidFill>
-            <a:srgbClr val="FFFFFF"/>
-          </a:solidFill>
-          <a:ln w="6350">
-            <a:solidFill>
-              <a:srgbClr val="E2E8F0"/>
-            </a:solidFill>
-          </a:ln>
-          <a:effectLst/>
-        </p:spPr>
-        <p:style>
-          <a:lnRef idx="1">
-            <a:schemeClr val="accent1"/>
-          </a:lnRef>
-          <a:fillRef idx="3">
-            <a:schemeClr val="accent1"/>
-          </a:fillRef>
-          <a:effectRef idx="2">
-            <a:schemeClr val="accent1"/>
-          </a:effectRef>
-          <a:fontRef idx="minor">
-            <a:schemeClr val="lt1"/>
-          </a:fontRef>
-        </p:style>
-        <p:txBody>
-          <a:bodyPr rtlCol="0" anchor="ctr"/>
-          <a:lstStyle/>
-          <a:p>
-            <a:pPr algn="ctr"/>
-          </a:p>
-        </p:txBody>
-      </p:sp>
-      <p:sp>
-        <p:nvSpPr>
-          <p:cNvPr id="46" name="TextBox 45"/>
-          <p:cNvSpPr txBox="1"/>
-          <p:nvPr/>
-        </p:nvSpPr>
-        <p:spPr>
-          <a:xfrm>
-            <a:off x="3977639" y="2999232"/>
-            <a:ext cx="1554480" cy="457200"/>
-          </a:xfrm>
-          <a:prstGeom prst="rect">
-            <a:avLst/>
-          </a:prstGeom>
-          <a:noFill/>
-        </p:spPr>
-        <p:txBody>
-          <a:bodyPr wrap="square" anchor="ctr" lIns="45720" rIns="45720" tIns="18288" bIns="9144">
-            <a:spAutoFit/>
-          </a:bodyPr>
-          <a:lstStyle/>
-          <a:p>
-            <a:pPr algn="ctr">
-              <a:lnSpc>
-                <a:spcPct val="103000"/>
-              </a:lnSpc>
-              <a:spcBef>
-                <a:spcPts val="0"/>
-              </a:spcBef>
-              <a:spcAft>
-                <a:spcPts val="0"/>
-              </a:spcAft>
-            </a:pPr>
-            <a:r>
-              <a:rPr sz="1100" b="0">
-                <a:solidFill>
-                  <a:srgbClr val="4A5568"/>
-                </a:solidFill>
-                <a:latin typeface="Calibri"/>
-              </a:rPr>
-              <a:t>10%</a:t>
-            </a:r>
-          </a:p>
-        </p:txBody>
-      </p:sp>
-      <p:sp>
-        <p:nvSpPr>
-          <p:cNvPr id="47" name="Rectangle 46"/>
-          <p:cNvSpPr/>
-          <p:nvPr/>
-        </p:nvSpPr>
-        <p:spPr>
-          <a:xfrm>
-            <a:off x="5532120" y="2999232"/>
-            <a:ext cx="1783080" cy="457200"/>
-          </a:xfrm>
-          <a:prstGeom prst="rect">
-            <a:avLst/>
-          </a:prstGeom>
-          <a:solidFill>
-            <a:srgbClr val="FFF1E6"/>
-          </a:solidFill>
-          <a:ln w="6350">
-            <a:solidFill>
-              <a:srgbClr val="E2E8F0"/>
-            </a:solidFill>
-          </a:ln>
-          <a:effectLst/>
-        </p:spPr>
-        <p:style>
-          <a:lnRef idx="1">
-            <a:schemeClr val="accent1"/>
-          </a:lnRef>
-          <a:fillRef idx="3">
-            <a:schemeClr val="accent1"/>
-          </a:fillRef>
-          <a:effectRef idx="2">
-            <a:schemeClr val="accent1"/>
-          </a:effectRef>
-          <a:fontRef idx="minor">
-            <a:schemeClr val="lt1"/>
-          </a:fontRef>
-        </p:style>
-        <p:txBody>
-          <a:bodyPr rtlCol="0" anchor="ctr"/>
-          <a:lstStyle/>
-          <a:p>
-            <a:pPr algn="ctr"/>
-          </a:p>
-        </p:txBody>
-      </p:sp>
-      <p:sp>
-        <p:nvSpPr>
-          <p:cNvPr id="48" name="TextBox 47"/>
-          <p:cNvSpPr txBox="1"/>
-          <p:nvPr/>
-        </p:nvSpPr>
-        <p:spPr>
-          <a:xfrm>
-            <a:off x="5532120" y="2999232"/>
-            <a:ext cx="1783080" cy="457200"/>
-          </a:xfrm>
-          <a:prstGeom prst="rect">
-            <a:avLst/>
-          </a:prstGeom>
-          <a:noFill/>
-        </p:spPr>
-        <p:txBody>
-          <a:bodyPr wrap="square" anchor="ctr" lIns="45720" rIns="45720" tIns="18288" bIns="9144">
-            <a:spAutoFit/>
-          </a:bodyPr>
-          <a:lstStyle/>
-          <a:p>
-            <a:pPr algn="ctr">
-              <a:lnSpc>
-                <a:spcPct val="103000"/>
-              </a:lnSpc>
-              <a:spcBef>
-                <a:spcPts val="0"/>
-              </a:spcBef>
-              <a:spcAft>
-                <a:spcPts val="0"/>
-              </a:spcAft>
-            </a:pPr>
-            <a:r>
-              <a:rPr sz="1100" b="1">
-                <a:solidFill>
-                  <a:srgbClr val="F5862C"/>
-                </a:solidFill>
-                <a:latin typeface="Calibri"/>
-              </a:rPr>
-              <a:t>10%</a:t>
-            </a:r>
-          </a:p>
-        </p:txBody>
-      </p:sp>
-      <p:sp>
-        <p:nvSpPr>
-          <p:cNvPr id="49" name="Rectangle 48"/>
-          <p:cNvSpPr/>
-          <p:nvPr/>
-        </p:nvSpPr>
-        <p:spPr>
-          <a:xfrm>
-            <a:off x="7315200" y="2999232"/>
-            <a:ext cx="1234440" cy="457200"/>
-          </a:xfrm>
-          <a:prstGeom prst="rect">
-            <a:avLst/>
-          </a:prstGeom>
-          <a:solidFill>
-            <a:srgbClr val="FFFFFF"/>
-          </a:solidFill>
-          <a:ln w="6350">
-            <a:solidFill>
-              <a:srgbClr val="E2E8F0"/>
-            </a:solidFill>
-          </a:ln>
-          <a:effectLst/>
-        </p:spPr>
-        <p:style>
-          <a:lnRef idx="1">
-            <a:schemeClr val="accent1"/>
-          </a:lnRef>
-          <a:fillRef idx="3">
-            <a:schemeClr val="accent1"/>
-          </a:fillRef>
-          <a:effectRef idx="2">
-            <a:schemeClr val="accent1"/>
-          </a:effectRef>
-          <a:fontRef idx="minor">
-            <a:schemeClr val="lt1"/>
-          </a:fontRef>
-        </p:style>
-        <p:txBody>
-          <a:bodyPr rtlCol="0" anchor="ctr"/>
-          <a:lstStyle/>
-          <a:p>
-            <a:pPr algn="ctr"/>
-          </a:p>
-        </p:txBody>
-      </p:sp>
-      <p:sp>
-        <p:nvSpPr>
-          <p:cNvPr id="50" name="TextBox 49"/>
-          <p:cNvSpPr txBox="1"/>
-          <p:nvPr/>
-        </p:nvSpPr>
-        <p:spPr>
-          <a:xfrm>
-            <a:off x="7315200" y="2999232"/>
-            <a:ext cx="1234440" cy="457200"/>
-          </a:xfrm>
-          <a:prstGeom prst="rect">
-            <a:avLst/>
-          </a:prstGeom>
-          <a:noFill/>
-        </p:spPr>
-        <p:txBody>
-          <a:bodyPr wrap="square" anchor="ctr" lIns="45720" rIns="45720" tIns="18288" bIns="9144">
-            <a:spAutoFit/>
-          </a:bodyPr>
-          <a:lstStyle/>
-          <a:p>
-            <a:pPr algn="ctr">
-              <a:lnSpc>
-                <a:spcPct val="103000"/>
-              </a:lnSpc>
-              <a:spcBef>
-                <a:spcPts val="0"/>
-              </a:spcBef>
-              <a:spcAft>
-                <a:spcPts val="0"/>
-              </a:spcAft>
-            </a:pPr>
-            <a:r>
-              <a:rPr sz="1100" b="0">
-                <a:solidFill>
-                  <a:srgbClr val="4A5568"/>
-                </a:solidFill>
-                <a:latin typeface="Calibri"/>
-              </a:rPr>
-              <a:t>20%</a:t>
-            </a:r>
-          </a:p>
-        </p:txBody>
-      </p:sp>
-      <p:sp>
-        <p:nvSpPr>
-          <p:cNvPr id="51" name="TextBox 50"/>
-          <p:cNvSpPr txBox="1"/>
-          <p:nvPr/>
-        </p:nvSpPr>
-        <p:spPr>
-          <a:xfrm>
-            <a:off x="411480" y="3346704"/>
-            <a:ext cx="8138160" cy="237744"/>
+            <a:off x="411480" y="4425696"/>
+            <a:ext cx="10972800" cy="201168"/>
           </a:xfrm>
           <a:prstGeom prst="rect">
             <a:avLst/>
@@ -7128,1113 +6951,21 @@
                 </a:solidFill>
                 <a:latin typeface="Calibri"/>
               </a:rPr>
-              <a:t>Cấu trúc biên trên 1 đơn vị (× 100% giá bán lẻ Zalo)</a:t>
-            </a:r>
-          </a:p>
-        </p:txBody>
-      </p:sp>
-      <p:sp>
-        <p:nvSpPr>
-          <p:cNvPr id="52" name="TextBox 51"/>
-          <p:cNvSpPr txBox="1"/>
-          <p:nvPr/>
-        </p:nvSpPr>
-        <p:spPr>
-          <a:xfrm>
-            <a:off x="411480" y="3657600"/>
-            <a:ext cx="1188720" cy="384048"/>
-          </a:xfrm>
-          <a:prstGeom prst="rect">
-            <a:avLst/>
-          </a:prstGeom>
-          <a:noFill/>
-        </p:spPr>
-        <p:txBody>
-          <a:bodyPr wrap="square" anchor="ctr" lIns="45720" rIns="45720" tIns="18288" bIns="9144">
-            <a:spAutoFit/>
-          </a:bodyPr>
-          <a:lstStyle/>
-          <a:p>
-            <a:pPr algn="l">
-              <a:lnSpc>
-                <a:spcPct val="103000"/>
-              </a:lnSpc>
-              <a:spcBef>
-                <a:spcPts val="0"/>
-              </a:spcBef>
-              <a:spcAft>
-                <a:spcPts val="0"/>
-              </a:spcAft>
-            </a:pPr>
-            <a:r>
-              <a:rPr sz="950" b="1">
-                <a:solidFill>
-                  <a:srgbClr val="001A40"/>
-                </a:solidFill>
-                <a:latin typeface="Calibri"/>
-              </a:rPr>
-              <a:t>Bậc 50–99</a:t>
-            </a:r>
-          </a:p>
-        </p:txBody>
-      </p:sp>
-      <p:sp>
-        <p:nvSpPr>
-          <p:cNvPr id="53" name="Rectangle 52"/>
+              <a:t>Ví dụ minh họa — zBusiness 12 tháng · Giá bán lẻ Zalo 1.990.000đ</a:t>
+            </a:r>
+          </a:p>
+        </p:txBody>
+      </p:sp>
+      <p:sp>
+        <p:nvSpPr>
+          <p:cNvPr id="45" name="Rounded Rectangle 44"/>
           <p:cNvSpPr/>
           <p:nvPr/>
         </p:nvSpPr>
         <p:spPr>
           <a:xfrm>
-            <a:off x="1691639" y="3657600"/>
-            <a:ext cx="5486400" cy="384048"/>
-          </a:xfrm>
-          <a:prstGeom prst="rect">
-            <a:avLst/>
-          </a:prstGeom>
-          <a:solidFill>
-            <a:srgbClr val="94A3B8"/>
-          </a:solidFill>
-          <a:ln>
-            <a:noFill/>
-          </a:ln>
-          <a:effectLst/>
-        </p:spPr>
-        <p:style>
-          <a:lnRef idx="1">
-            <a:schemeClr val="accent1"/>
-          </a:lnRef>
-          <a:fillRef idx="3">
-            <a:schemeClr val="accent1"/>
-          </a:fillRef>
-          <a:effectRef idx="2">
-            <a:schemeClr val="accent1"/>
-          </a:effectRef>
-          <a:fontRef idx="minor">
-            <a:schemeClr val="lt1"/>
-          </a:fontRef>
-        </p:style>
-        <p:txBody>
-          <a:bodyPr rtlCol="0" anchor="ctr"/>
-          <a:lstStyle/>
-          <a:p>
-            <a:pPr algn="ctr"/>
-          </a:p>
-        </p:txBody>
-      </p:sp>
-      <p:sp>
-        <p:nvSpPr>
-          <p:cNvPr id="54" name="TextBox 53"/>
-          <p:cNvSpPr txBox="1"/>
-          <p:nvPr/>
-        </p:nvSpPr>
-        <p:spPr>
-          <a:xfrm>
-            <a:off x="1691639" y="3657600"/>
-            <a:ext cx="5486400" cy="384048"/>
-          </a:xfrm>
-          <a:prstGeom prst="rect">
-            <a:avLst/>
-          </a:prstGeom>
-          <a:noFill/>
-        </p:spPr>
-        <p:txBody>
-          <a:bodyPr wrap="square" anchor="ctr" lIns="45720" rIns="45720" tIns="18288" bIns="9144">
-            <a:spAutoFit/>
-          </a:bodyPr>
-          <a:lstStyle/>
-          <a:p>
-            <a:pPr algn="ctr">
-              <a:lnSpc>
-                <a:spcPct val="103000"/>
-              </a:lnSpc>
-              <a:spcBef>
-                <a:spcPts val="0"/>
-              </a:spcBef>
-              <a:spcAft>
-                <a:spcPts val="0"/>
-              </a:spcAft>
-            </a:pPr>
-            <a:r>
-              <a:rPr sz="850" b="1">
-                <a:solidFill>
-                  <a:srgbClr val="FFFFFF"/>
-                </a:solidFill>
-                <a:latin typeface="Calibri"/>
-              </a:rPr>
-              <a:t>Giá VNG 80%</a:t>
-            </a:r>
-          </a:p>
-        </p:txBody>
-      </p:sp>
-      <p:sp>
-        <p:nvSpPr>
-          <p:cNvPr id="55" name="Rectangle 54"/>
-          <p:cNvSpPr/>
-          <p:nvPr/>
-        </p:nvSpPr>
-        <p:spPr>
-          <a:xfrm>
-            <a:off x="7178040" y="3657600"/>
-            <a:ext cx="1028700" cy="384048"/>
-          </a:xfrm>
-          <a:prstGeom prst="rect">
-            <a:avLst/>
-          </a:prstGeom>
-          <a:solidFill>
-            <a:srgbClr val="F5862C"/>
-          </a:solidFill>
-          <a:ln>
-            <a:noFill/>
-          </a:ln>
-          <a:effectLst/>
-        </p:spPr>
-        <p:style>
-          <a:lnRef idx="1">
-            <a:schemeClr val="accent1"/>
-          </a:lnRef>
-          <a:fillRef idx="3">
-            <a:schemeClr val="accent1"/>
-          </a:fillRef>
-          <a:effectRef idx="2">
-            <a:schemeClr val="accent1"/>
-          </a:effectRef>
-          <a:fontRef idx="minor">
-            <a:schemeClr val="lt1"/>
-          </a:fontRef>
-        </p:style>
-        <p:txBody>
-          <a:bodyPr rtlCol="0" anchor="ctr"/>
-          <a:lstStyle/>
-          <a:p>
-            <a:pPr algn="ctr"/>
-          </a:p>
-        </p:txBody>
-      </p:sp>
-      <p:sp>
-        <p:nvSpPr>
-          <p:cNvPr id="56" name="TextBox 55"/>
-          <p:cNvSpPr txBox="1"/>
-          <p:nvPr/>
-        </p:nvSpPr>
-        <p:spPr>
-          <a:xfrm>
-            <a:off x="7178040" y="3657600"/>
-            <a:ext cx="1028700" cy="384048"/>
-          </a:xfrm>
-          <a:prstGeom prst="rect">
-            <a:avLst/>
-          </a:prstGeom>
-          <a:noFill/>
-        </p:spPr>
-        <p:txBody>
-          <a:bodyPr wrap="square" anchor="ctr" lIns="45720" rIns="45720" tIns="18288" bIns="9144">
-            <a:spAutoFit/>
-          </a:bodyPr>
-          <a:lstStyle/>
-          <a:p>
-            <a:pPr algn="ctr">
-              <a:lnSpc>
-                <a:spcPct val="103000"/>
-              </a:lnSpc>
-              <a:spcBef>
-                <a:spcPts val="0"/>
-              </a:spcBef>
-              <a:spcAft>
-                <a:spcPts val="0"/>
-              </a:spcAft>
-            </a:pPr>
-            <a:r>
-              <a:rPr sz="850" b="1">
-                <a:solidFill>
-                  <a:srgbClr val="FFFFFF"/>
-                </a:solidFill>
-                <a:latin typeface="Calibri"/>
-              </a:rPr>
-              <a:t>GAPIT 15%</a:t>
-            </a:r>
-          </a:p>
-        </p:txBody>
-      </p:sp>
-      <p:sp>
-        <p:nvSpPr>
-          <p:cNvPr id="57" name="Rectangle 56"/>
-          <p:cNvSpPr/>
-          <p:nvPr/>
-        </p:nvSpPr>
-        <p:spPr>
-          <a:xfrm>
-            <a:off x="8206740" y="3657600"/>
-            <a:ext cx="342900" cy="384048"/>
-          </a:xfrm>
-          <a:prstGeom prst="rect">
-            <a:avLst/>
-          </a:prstGeom>
-          <a:solidFill>
-            <a:srgbClr val="22C55E"/>
-          </a:solidFill>
-          <a:ln>
-            <a:noFill/>
-          </a:ln>
-          <a:effectLst/>
-        </p:spPr>
-        <p:style>
-          <a:lnRef idx="1">
-            <a:schemeClr val="accent1"/>
-          </a:lnRef>
-          <a:fillRef idx="3">
-            <a:schemeClr val="accent1"/>
-          </a:fillRef>
-          <a:effectRef idx="2">
-            <a:schemeClr val="accent1"/>
-          </a:effectRef>
-          <a:fontRef idx="minor">
-            <a:schemeClr val="lt1"/>
-          </a:fontRef>
-        </p:style>
-        <p:txBody>
-          <a:bodyPr rtlCol="0" anchor="ctr"/>
-          <a:lstStyle/>
-          <a:p>
-            <a:pPr algn="ctr"/>
-          </a:p>
-        </p:txBody>
-      </p:sp>
-      <p:sp>
-        <p:nvSpPr>
-          <p:cNvPr id="58" name="TextBox 57"/>
-          <p:cNvSpPr txBox="1"/>
-          <p:nvPr/>
-        </p:nvSpPr>
-        <p:spPr>
-          <a:xfrm>
-            <a:off x="8206740" y="3657600"/>
-            <a:ext cx="342900" cy="384048"/>
-          </a:xfrm>
-          <a:prstGeom prst="rect">
-            <a:avLst/>
-          </a:prstGeom>
-          <a:noFill/>
-        </p:spPr>
-        <p:txBody>
-          <a:bodyPr wrap="square" anchor="ctr" lIns="45720" rIns="45720" tIns="18288" bIns="9144">
-            <a:spAutoFit/>
-          </a:bodyPr>
-          <a:lstStyle/>
-          <a:p>
-            <a:pPr algn="ctr">
-              <a:lnSpc>
-                <a:spcPct val="103000"/>
-              </a:lnSpc>
-              <a:spcBef>
-                <a:spcPts val="0"/>
-              </a:spcBef>
-              <a:spcAft>
-                <a:spcPts val="0"/>
-              </a:spcAft>
-            </a:pPr>
-            <a:r>
-              <a:rPr sz="850" b="1">
-                <a:solidFill>
-                  <a:srgbClr val="FFFFFF"/>
-                </a:solidFill>
-                <a:latin typeface="Calibri"/>
-              </a:rPr>
-              <a:t>ĐL 5%</a:t>
-            </a:r>
-          </a:p>
-        </p:txBody>
-      </p:sp>
-      <p:sp>
-        <p:nvSpPr>
-          <p:cNvPr id="59" name="TextBox 58"/>
-          <p:cNvSpPr txBox="1"/>
-          <p:nvPr/>
-        </p:nvSpPr>
-        <p:spPr>
-          <a:xfrm>
-            <a:off x="411480" y="4133087"/>
-            <a:ext cx="1188720" cy="384048"/>
-          </a:xfrm>
-          <a:prstGeom prst="rect">
-            <a:avLst/>
-          </a:prstGeom>
-          <a:noFill/>
-        </p:spPr>
-        <p:txBody>
-          <a:bodyPr wrap="square" anchor="ctr" lIns="45720" rIns="45720" tIns="18288" bIns="9144">
-            <a:spAutoFit/>
-          </a:bodyPr>
-          <a:lstStyle/>
-          <a:p>
-            <a:pPr algn="l">
-              <a:lnSpc>
-                <a:spcPct val="103000"/>
-              </a:lnSpc>
-              <a:spcBef>
-                <a:spcPts val="0"/>
-              </a:spcBef>
-              <a:spcAft>
-                <a:spcPts val="0"/>
-              </a:spcAft>
-            </a:pPr>
-            <a:r>
-              <a:rPr sz="950" b="1">
-                <a:solidFill>
-                  <a:srgbClr val="001A40"/>
-                </a:solidFill>
-                <a:latin typeface="Calibri"/>
-              </a:rPr>
-              <a:t>Bậc 100–299</a:t>
-            </a:r>
-          </a:p>
-        </p:txBody>
-      </p:sp>
-      <p:sp>
-        <p:nvSpPr>
-          <p:cNvPr id="60" name="Rectangle 59"/>
-          <p:cNvSpPr/>
-          <p:nvPr/>
-        </p:nvSpPr>
-        <p:spPr>
-          <a:xfrm>
-            <a:off x="1691639" y="4133087"/>
-            <a:ext cx="5486400" cy="384048"/>
-          </a:xfrm>
-          <a:prstGeom prst="rect">
-            <a:avLst/>
-          </a:prstGeom>
-          <a:solidFill>
-            <a:srgbClr val="94A3B8"/>
-          </a:solidFill>
-          <a:ln>
-            <a:noFill/>
-          </a:ln>
-          <a:effectLst/>
-        </p:spPr>
-        <p:style>
-          <a:lnRef idx="1">
-            <a:schemeClr val="accent1"/>
-          </a:lnRef>
-          <a:fillRef idx="3">
-            <a:schemeClr val="accent1"/>
-          </a:fillRef>
-          <a:effectRef idx="2">
-            <a:schemeClr val="accent1"/>
-          </a:effectRef>
-          <a:fontRef idx="minor">
-            <a:schemeClr val="lt1"/>
-          </a:fontRef>
-        </p:style>
-        <p:txBody>
-          <a:bodyPr rtlCol="0" anchor="ctr"/>
-          <a:lstStyle/>
-          <a:p>
-            <a:pPr algn="ctr"/>
-          </a:p>
-        </p:txBody>
-      </p:sp>
-      <p:sp>
-        <p:nvSpPr>
-          <p:cNvPr id="61" name="TextBox 60"/>
-          <p:cNvSpPr txBox="1"/>
-          <p:nvPr/>
-        </p:nvSpPr>
-        <p:spPr>
-          <a:xfrm>
-            <a:off x="1691639" y="4133087"/>
-            <a:ext cx="5486400" cy="384048"/>
-          </a:xfrm>
-          <a:prstGeom prst="rect">
-            <a:avLst/>
-          </a:prstGeom>
-          <a:noFill/>
-        </p:spPr>
-        <p:txBody>
-          <a:bodyPr wrap="square" anchor="ctr" lIns="45720" rIns="45720" tIns="18288" bIns="9144">
-            <a:spAutoFit/>
-          </a:bodyPr>
-          <a:lstStyle/>
-          <a:p>
-            <a:pPr algn="ctr">
-              <a:lnSpc>
-                <a:spcPct val="103000"/>
-              </a:lnSpc>
-              <a:spcBef>
-                <a:spcPts val="0"/>
-              </a:spcBef>
-              <a:spcAft>
-                <a:spcPts val="0"/>
-              </a:spcAft>
-            </a:pPr>
-            <a:r>
-              <a:rPr sz="850" b="1">
-                <a:solidFill>
-                  <a:srgbClr val="FFFFFF"/>
-                </a:solidFill>
-                <a:latin typeface="Calibri"/>
-              </a:rPr>
-              <a:t>Giá VNG 80%</a:t>
-            </a:r>
-          </a:p>
-        </p:txBody>
-      </p:sp>
-      <p:sp>
-        <p:nvSpPr>
-          <p:cNvPr id="62" name="Rectangle 61"/>
-          <p:cNvSpPr/>
-          <p:nvPr/>
-        </p:nvSpPr>
-        <p:spPr>
-          <a:xfrm>
-            <a:off x="7178040" y="4133087"/>
-            <a:ext cx="822960" cy="384048"/>
-          </a:xfrm>
-          <a:prstGeom prst="rect">
-            <a:avLst/>
-          </a:prstGeom>
-          <a:solidFill>
-            <a:srgbClr val="F5862C"/>
-          </a:solidFill>
-          <a:ln>
-            <a:noFill/>
-          </a:ln>
-          <a:effectLst/>
-        </p:spPr>
-        <p:style>
-          <a:lnRef idx="1">
-            <a:schemeClr val="accent1"/>
-          </a:lnRef>
-          <a:fillRef idx="3">
-            <a:schemeClr val="accent1"/>
-          </a:fillRef>
-          <a:effectRef idx="2">
-            <a:schemeClr val="accent1"/>
-          </a:effectRef>
-          <a:fontRef idx="minor">
-            <a:schemeClr val="lt1"/>
-          </a:fontRef>
-        </p:style>
-        <p:txBody>
-          <a:bodyPr rtlCol="0" anchor="ctr"/>
-          <a:lstStyle/>
-          <a:p>
-            <a:pPr algn="ctr"/>
-          </a:p>
-        </p:txBody>
-      </p:sp>
-      <p:sp>
-        <p:nvSpPr>
-          <p:cNvPr id="63" name="TextBox 62"/>
-          <p:cNvSpPr txBox="1"/>
-          <p:nvPr/>
-        </p:nvSpPr>
-        <p:spPr>
-          <a:xfrm>
-            <a:off x="7178040" y="4133087"/>
-            <a:ext cx="822960" cy="384048"/>
-          </a:xfrm>
-          <a:prstGeom prst="rect">
-            <a:avLst/>
-          </a:prstGeom>
-          <a:noFill/>
-        </p:spPr>
-        <p:txBody>
-          <a:bodyPr wrap="square" anchor="ctr" lIns="45720" rIns="45720" tIns="18288" bIns="9144">
-            <a:spAutoFit/>
-          </a:bodyPr>
-          <a:lstStyle/>
-          <a:p>
-            <a:pPr algn="ctr">
-              <a:lnSpc>
-                <a:spcPct val="103000"/>
-              </a:lnSpc>
-              <a:spcBef>
-                <a:spcPts val="0"/>
-              </a:spcBef>
-              <a:spcAft>
-                <a:spcPts val="0"/>
-              </a:spcAft>
-            </a:pPr>
-            <a:r>
-              <a:rPr sz="850" b="1">
-                <a:solidFill>
-                  <a:srgbClr val="FFFFFF"/>
-                </a:solidFill>
-                <a:latin typeface="Calibri"/>
-              </a:rPr>
-              <a:t>GAPIT 12%</a:t>
-            </a:r>
-          </a:p>
-        </p:txBody>
-      </p:sp>
-      <p:sp>
-        <p:nvSpPr>
-          <p:cNvPr id="64" name="Rectangle 63"/>
-          <p:cNvSpPr/>
-          <p:nvPr/>
-        </p:nvSpPr>
-        <p:spPr>
-          <a:xfrm>
-            <a:off x="8001000" y="4133087"/>
-            <a:ext cx="548640" cy="384048"/>
-          </a:xfrm>
-          <a:prstGeom prst="rect">
-            <a:avLst/>
-          </a:prstGeom>
-          <a:solidFill>
-            <a:srgbClr val="22C55E"/>
-          </a:solidFill>
-          <a:ln>
-            <a:noFill/>
-          </a:ln>
-          <a:effectLst/>
-        </p:spPr>
-        <p:style>
-          <a:lnRef idx="1">
-            <a:schemeClr val="accent1"/>
-          </a:lnRef>
-          <a:fillRef idx="3">
-            <a:schemeClr val="accent1"/>
-          </a:fillRef>
-          <a:effectRef idx="2">
-            <a:schemeClr val="accent1"/>
-          </a:effectRef>
-          <a:fontRef idx="minor">
-            <a:schemeClr val="lt1"/>
-          </a:fontRef>
-        </p:style>
-        <p:txBody>
-          <a:bodyPr rtlCol="0" anchor="ctr"/>
-          <a:lstStyle/>
-          <a:p>
-            <a:pPr algn="ctr"/>
-          </a:p>
-        </p:txBody>
-      </p:sp>
-      <p:sp>
-        <p:nvSpPr>
-          <p:cNvPr id="65" name="TextBox 64"/>
-          <p:cNvSpPr txBox="1"/>
-          <p:nvPr/>
-        </p:nvSpPr>
-        <p:spPr>
-          <a:xfrm>
-            <a:off x="8001000" y="4133087"/>
-            <a:ext cx="548640" cy="384048"/>
-          </a:xfrm>
-          <a:prstGeom prst="rect">
-            <a:avLst/>
-          </a:prstGeom>
-          <a:noFill/>
-        </p:spPr>
-        <p:txBody>
-          <a:bodyPr wrap="square" anchor="ctr" lIns="45720" rIns="45720" tIns="18288" bIns="9144">
-            <a:spAutoFit/>
-          </a:bodyPr>
-          <a:lstStyle/>
-          <a:p>
-            <a:pPr algn="ctr">
-              <a:lnSpc>
-                <a:spcPct val="103000"/>
-              </a:lnSpc>
-              <a:spcBef>
-                <a:spcPts val="0"/>
-              </a:spcBef>
-              <a:spcAft>
-                <a:spcPts val="0"/>
-              </a:spcAft>
-            </a:pPr>
-            <a:r>
-              <a:rPr sz="850" b="1">
-                <a:solidFill>
-                  <a:srgbClr val="FFFFFF"/>
-                </a:solidFill>
-                <a:latin typeface="Calibri"/>
-              </a:rPr>
-              <a:t>ĐL 8%</a:t>
-            </a:r>
-          </a:p>
-        </p:txBody>
-      </p:sp>
-      <p:sp>
-        <p:nvSpPr>
-          <p:cNvPr id="66" name="TextBox 65"/>
-          <p:cNvSpPr txBox="1"/>
-          <p:nvPr/>
-        </p:nvSpPr>
-        <p:spPr>
-          <a:xfrm>
-            <a:off x="411480" y="4608576"/>
-            <a:ext cx="1188720" cy="384048"/>
-          </a:xfrm>
-          <a:prstGeom prst="rect">
-            <a:avLst/>
-          </a:prstGeom>
-          <a:noFill/>
-        </p:spPr>
-        <p:txBody>
-          <a:bodyPr wrap="square" anchor="ctr" lIns="45720" rIns="45720" tIns="18288" bIns="9144">
-            <a:spAutoFit/>
-          </a:bodyPr>
-          <a:lstStyle/>
-          <a:p>
-            <a:pPr algn="l">
-              <a:lnSpc>
-                <a:spcPct val="103000"/>
-              </a:lnSpc>
-              <a:spcBef>
-                <a:spcPts val="0"/>
-              </a:spcBef>
-              <a:spcAft>
-                <a:spcPts val="0"/>
-              </a:spcAft>
-            </a:pPr>
-            <a:r>
-              <a:rPr sz="950" b="1">
-                <a:solidFill>
-                  <a:srgbClr val="001A40"/>
-                </a:solidFill>
-                <a:latin typeface="Calibri"/>
-              </a:rPr>
-              <a:t>Bậc ≥300</a:t>
-            </a:r>
-          </a:p>
-        </p:txBody>
-      </p:sp>
-      <p:sp>
-        <p:nvSpPr>
-          <p:cNvPr id="67" name="Rectangle 66"/>
-          <p:cNvSpPr/>
-          <p:nvPr/>
-        </p:nvSpPr>
-        <p:spPr>
-          <a:xfrm>
-            <a:off x="1691639" y="4608576"/>
-            <a:ext cx="5486400" cy="384048"/>
-          </a:xfrm>
-          <a:prstGeom prst="rect">
-            <a:avLst/>
-          </a:prstGeom>
-          <a:solidFill>
-            <a:srgbClr val="94A3B8"/>
-          </a:solidFill>
-          <a:ln>
-            <a:noFill/>
-          </a:ln>
-          <a:effectLst/>
-        </p:spPr>
-        <p:style>
-          <a:lnRef idx="1">
-            <a:schemeClr val="accent1"/>
-          </a:lnRef>
-          <a:fillRef idx="3">
-            <a:schemeClr val="accent1"/>
-          </a:fillRef>
-          <a:effectRef idx="2">
-            <a:schemeClr val="accent1"/>
-          </a:effectRef>
-          <a:fontRef idx="minor">
-            <a:schemeClr val="lt1"/>
-          </a:fontRef>
-        </p:style>
-        <p:txBody>
-          <a:bodyPr rtlCol="0" anchor="ctr"/>
-          <a:lstStyle/>
-          <a:p>
-            <a:pPr algn="ctr"/>
-          </a:p>
-        </p:txBody>
-      </p:sp>
-      <p:sp>
-        <p:nvSpPr>
-          <p:cNvPr id="68" name="TextBox 67"/>
-          <p:cNvSpPr txBox="1"/>
-          <p:nvPr/>
-        </p:nvSpPr>
-        <p:spPr>
-          <a:xfrm>
-            <a:off x="1691639" y="4608576"/>
-            <a:ext cx="5486400" cy="384048"/>
-          </a:xfrm>
-          <a:prstGeom prst="rect">
-            <a:avLst/>
-          </a:prstGeom>
-          <a:noFill/>
-        </p:spPr>
-        <p:txBody>
-          <a:bodyPr wrap="square" anchor="ctr" lIns="45720" rIns="45720" tIns="18288" bIns="9144">
-            <a:spAutoFit/>
-          </a:bodyPr>
-          <a:lstStyle/>
-          <a:p>
-            <a:pPr algn="ctr">
-              <a:lnSpc>
-                <a:spcPct val="103000"/>
-              </a:lnSpc>
-              <a:spcBef>
-                <a:spcPts val="0"/>
-              </a:spcBef>
-              <a:spcAft>
-                <a:spcPts val="0"/>
-              </a:spcAft>
-            </a:pPr>
-            <a:r>
-              <a:rPr sz="850" b="1">
-                <a:solidFill>
-                  <a:srgbClr val="FFFFFF"/>
-                </a:solidFill>
-                <a:latin typeface="Calibri"/>
-              </a:rPr>
-              <a:t>Giá VNG 80%</a:t>
-            </a:r>
-          </a:p>
-        </p:txBody>
-      </p:sp>
-      <p:sp>
-        <p:nvSpPr>
-          <p:cNvPr id="69" name="Rectangle 68"/>
-          <p:cNvSpPr/>
-          <p:nvPr/>
-        </p:nvSpPr>
-        <p:spPr>
-          <a:xfrm>
-            <a:off x="7178040" y="4608576"/>
-            <a:ext cx="685800" cy="384048"/>
-          </a:xfrm>
-          <a:prstGeom prst="rect">
-            <a:avLst/>
-          </a:prstGeom>
-          <a:solidFill>
-            <a:srgbClr val="F5862C"/>
-          </a:solidFill>
-          <a:ln>
-            <a:noFill/>
-          </a:ln>
-          <a:effectLst/>
-        </p:spPr>
-        <p:style>
-          <a:lnRef idx="1">
-            <a:schemeClr val="accent1"/>
-          </a:lnRef>
-          <a:fillRef idx="3">
-            <a:schemeClr val="accent1"/>
-          </a:fillRef>
-          <a:effectRef idx="2">
-            <a:schemeClr val="accent1"/>
-          </a:effectRef>
-          <a:fontRef idx="minor">
-            <a:schemeClr val="lt1"/>
-          </a:fontRef>
-        </p:style>
-        <p:txBody>
-          <a:bodyPr rtlCol="0" anchor="ctr"/>
-          <a:lstStyle/>
-          <a:p>
-            <a:pPr algn="ctr"/>
-          </a:p>
-        </p:txBody>
-      </p:sp>
-      <p:sp>
-        <p:nvSpPr>
-          <p:cNvPr id="70" name="TextBox 69"/>
-          <p:cNvSpPr txBox="1"/>
-          <p:nvPr/>
-        </p:nvSpPr>
-        <p:spPr>
-          <a:xfrm>
-            <a:off x="7178040" y="4608576"/>
-            <a:ext cx="685800" cy="384048"/>
-          </a:xfrm>
-          <a:prstGeom prst="rect">
-            <a:avLst/>
-          </a:prstGeom>
-          <a:noFill/>
-        </p:spPr>
-        <p:txBody>
-          <a:bodyPr wrap="square" anchor="ctr" lIns="45720" rIns="45720" tIns="18288" bIns="9144">
-            <a:spAutoFit/>
-          </a:bodyPr>
-          <a:lstStyle/>
-          <a:p>
-            <a:pPr algn="ctr">
-              <a:lnSpc>
-                <a:spcPct val="103000"/>
-              </a:lnSpc>
-              <a:spcBef>
-                <a:spcPts val="0"/>
-              </a:spcBef>
-              <a:spcAft>
-                <a:spcPts val="0"/>
-              </a:spcAft>
-            </a:pPr>
-            <a:r>
-              <a:rPr sz="850" b="1">
-                <a:solidFill>
-                  <a:srgbClr val="FFFFFF"/>
-                </a:solidFill>
-                <a:latin typeface="Calibri"/>
-              </a:rPr>
-              <a:t>GAPIT 10%</a:t>
-            </a:r>
-          </a:p>
-        </p:txBody>
-      </p:sp>
-      <p:sp>
-        <p:nvSpPr>
-          <p:cNvPr id="71" name="Rectangle 70"/>
-          <p:cNvSpPr/>
-          <p:nvPr/>
-        </p:nvSpPr>
-        <p:spPr>
-          <a:xfrm>
-            <a:off x="7863840" y="4608576"/>
-            <a:ext cx="685800" cy="384048"/>
-          </a:xfrm>
-          <a:prstGeom prst="rect">
-            <a:avLst/>
-          </a:prstGeom>
-          <a:solidFill>
-            <a:srgbClr val="22C55E"/>
-          </a:solidFill>
-          <a:ln>
-            <a:noFill/>
-          </a:ln>
-          <a:effectLst/>
-        </p:spPr>
-        <p:style>
-          <a:lnRef idx="1">
-            <a:schemeClr val="accent1"/>
-          </a:lnRef>
-          <a:fillRef idx="3">
-            <a:schemeClr val="accent1"/>
-          </a:fillRef>
-          <a:effectRef idx="2">
-            <a:schemeClr val="accent1"/>
-          </a:effectRef>
-          <a:fontRef idx="minor">
-            <a:schemeClr val="lt1"/>
-          </a:fontRef>
-        </p:style>
-        <p:txBody>
-          <a:bodyPr rtlCol="0" anchor="ctr"/>
-          <a:lstStyle/>
-          <a:p>
-            <a:pPr algn="ctr"/>
-          </a:p>
-        </p:txBody>
-      </p:sp>
-      <p:sp>
-        <p:nvSpPr>
-          <p:cNvPr id="72" name="TextBox 71"/>
-          <p:cNvSpPr txBox="1"/>
-          <p:nvPr/>
-        </p:nvSpPr>
-        <p:spPr>
-          <a:xfrm>
-            <a:off x="7863840" y="4608576"/>
-            <a:ext cx="685800" cy="384048"/>
-          </a:xfrm>
-          <a:prstGeom prst="rect">
-            <a:avLst/>
-          </a:prstGeom>
-          <a:noFill/>
-        </p:spPr>
-        <p:txBody>
-          <a:bodyPr wrap="square" anchor="ctr" lIns="45720" rIns="45720" tIns="18288" bIns="9144">
-            <a:spAutoFit/>
-          </a:bodyPr>
-          <a:lstStyle/>
-          <a:p>
-            <a:pPr algn="ctr">
-              <a:lnSpc>
-                <a:spcPct val="103000"/>
-              </a:lnSpc>
-              <a:spcBef>
-                <a:spcPts val="0"/>
-              </a:spcBef>
-              <a:spcAft>
-                <a:spcPts val="0"/>
-              </a:spcAft>
-            </a:pPr>
-            <a:r>
-              <a:rPr sz="850" b="1">
-                <a:solidFill>
-                  <a:srgbClr val="FFFFFF"/>
-                </a:solidFill>
-                <a:latin typeface="Calibri"/>
-              </a:rPr>
-              <a:t>ĐL 10%</a:t>
-            </a:r>
-          </a:p>
-        </p:txBody>
-      </p:sp>
-      <p:sp>
-        <p:nvSpPr>
-          <p:cNvPr id="73" name="Rounded Rectangle 72"/>
-          <p:cNvSpPr/>
-          <p:nvPr/>
-        </p:nvSpPr>
-        <p:spPr>
-          <a:xfrm>
-            <a:off x="9144000" y="1627632"/>
-            <a:ext cx="2651760" cy="365760"/>
-          </a:xfrm>
-          <a:prstGeom prst="roundRect">
-            <a:avLst/>
-          </a:prstGeom>
-          <a:solidFill>
-            <a:srgbClr val="001A40"/>
-          </a:solidFill>
-          <a:ln>
-            <a:noFill/>
-          </a:ln>
-          <a:effectLst/>
-        </p:spPr>
-        <p:style>
-          <a:lnRef idx="1">
-            <a:schemeClr val="accent1"/>
-          </a:lnRef>
-          <a:fillRef idx="3">
-            <a:schemeClr val="accent1"/>
-          </a:fillRef>
-          <a:effectRef idx="2">
-            <a:schemeClr val="accent1"/>
-          </a:effectRef>
-          <a:fontRef idx="minor">
-            <a:schemeClr val="lt1"/>
-          </a:fontRef>
-        </p:style>
-        <p:txBody>
-          <a:bodyPr rtlCol="0" anchor="ctr"/>
-          <a:lstStyle/>
-          <a:p>
-            <a:pPr algn="ctr"/>
-          </a:p>
-        </p:txBody>
-      </p:sp>
-      <p:sp>
-        <p:nvSpPr>
-          <p:cNvPr id="74" name="TextBox 73"/>
-          <p:cNvSpPr txBox="1"/>
-          <p:nvPr/>
-        </p:nvSpPr>
-        <p:spPr>
-          <a:xfrm>
-            <a:off x="9144000" y="1627632"/>
-            <a:ext cx="2651760" cy="365760"/>
-          </a:xfrm>
-          <a:prstGeom prst="rect">
-            <a:avLst/>
-          </a:prstGeom>
-          <a:noFill/>
-        </p:spPr>
-        <p:txBody>
-          <a:bodyPr wrap="square" anchor="ctr" lIns="45720" rIns="45720" tIns="18288" bIns="9144">
-            <a:spAutoFit/>
-          </a:bodyPr>
-          <a:lstStyle/>
-          <a:p>
-            <a:pPr algn="ctr">
-              <a:lnSpc>
-                <a:spcPct val="103000"/>
-              </a:lnSpc>
-              <a:spcBef>
-                <a:spcPts val="0"/>
-              </a:spcBef>
-              <a:spcAft>
-                <a:spcPts val="0"/>
-              </a:spcAft>
-            </a:pPr>
-            <a:r>
-              <a:rPr sz="1000" b="1">
-                <a:solidFill>
-                  <a:srgbClr val="FFFFFF"/>
-                </a:solidFill>
-                <a:latin typeface="Calibri"/>
-              </a:rPr>
-              <a:t>VÍ DỤ — zBusiness 12 tháng</a:t>
-            </a:r>
-          </a:p>
-        </p:txBody>
-      </p:sp>
-      <p:sp>
-        <p:nvSpPr>
-          <p:cNvPr id="75" name="TextBox 74"/>
-          <p:cNvSpPr txBox="1"/>
-          <p:nvPr/>
-        </p:nvSpPr>
-        <p:spPr>
-          <a:xfrm>
-            <a:off x="9144000" y="2066543"/>
-            <a:ext cx="2651760" cy="457200"/>
-          </a:xfrm>
-          <a:prstGeom prst="rect">
-            <a:avLst/>
-          </a:prstGeom>
-          <a:noFill/>
-        </p:spPr>
-        <p:txBody>
-          <a:bodyPr wrap="square" anchor="t" lIns="45720" rIns="45720" tIns="18288" bIns="9144">
-            <a:spAutoFit/>
-          </a:bodyPr>
-          <a:lstStyle/>
-          <a:p>
-            <a:pPr algn="l">
-              <a:lnSpc>
-                <a:spcPct val="103000"/>
-              </a:lnSpc>
-              <a:spcBef>
-                <a:spcPts val="0"/>
-              </a:spcBef>
-              <a:spcAft>
-                <a:spcPts val="0"/>
-              </a:spcAft>
-            </a:pPr>
-            <a:r>
-              <a:rPr sz="1050" b="1">
-                <a:solidFill>
-                  <a:srgbClr val="001A40"/>
-                </a:solidFill>
-                <a:latin typeface="Calibri"/>
-              </a:rPr>
-              <a:t>Zalo retail 1.990.000đ</a:t>
-            </a:r>
-          </a:p>
-          <a:p>
-            <a:pPr algn="l">
-              <a:lnSpc>
-                <a:spcPct val="103000"/>
-              </a:lnSpc>
-              <a:spcBef>
-                <a:spcPts val="100"/>
-              </a:spcBef>
-              <a:spcAft>
-                <a:spcPts val="0"/>
-              </a:spcAft>
-            </a:pPr>
-            <a:r>
-              <a:rPr sz="950" b="0">
-                <a:solidFill>
-                  <a:srgbClr val="4A5568"/>
-                </a:solidFill>
-                <a:latin typeface="Calibri"/>
-              </a:rPr>
-              <a:t>VNG → GAPIT 1.592.000đ (−20%)</a:t>
-            </a:r>
-          </a:p>
-        </p:txBody>
-      </p:sp>
-      <p:sp>
-        <p:nvSpPr>
-          <p:cNvPr id="76" name="Rounded Rectangle 75"/>
-          <p:cNvSpPr/>
-          <p:nvPr/>
-        </p:nvSpPr>
-        <p:spPr>
-          <a:xfrm>
-            <a:off x="9144000" y="2615184"/>
-            <a:ext cx="2651760" cy="1078992"/>
+            <a:off x="411480" y="4663440"/>
+            <a:ext cx="3703320" cy="1207008"/>
           </a:xfrm>
           <a:prstGeom prst="roundRect">
             <a:avLst/>
@@ -8273,14 +7004,14 @@
       </p:sp>
       <p:sp>
         <p:nvSpPr>
-          <p:cNvPr id="77" name="Rectangle 76"/>
+          <p:cNvPr id="46" name="Rectangle 45"/>
           <p:cNvSpPr/>
           <p:nvPr/>
         </p:nvSpPr>
         <p:spPr>
           <a:xfrm>
-            <a:off x="9144000" y="2615184"/>
-            <a:ext cx="91440" cy="1078992"/>
+            <a:off x="411480" y="4663440"/>
+            <a:ext cx="91440" cy="1207008"/>
           </a:xfrm>
           <a:prstGeom prst="rect">
             <a:avLst/>
@@ -8317,14 +7048,14 @@
       </p:sp>
       <p:sp>
         <p:nvSpPr>
-          <p:cNvPr id="78" name="TextBox 77"/>
+          <p:cNvPr id="47" name="TextBox 46"/>
           <p:cNvSpPr txBox="1"/>
           <p:nvPr/>
         </p:nvSpPr>
         <p:spPr>
           <a:xfrm>
-            <a:off x="9326880" y="2670048"/>
-            <a:ext cx="2377440" cy="237744"/>
+            <a:off x="612648" y="4709160"/>
+            <a:ext cx="3429000" cy="420624"/>
           </a:xfrm>
           <a:prstGeom prst="rect">
             <a:avLst/>
@@ -8349,27 +7080,27 @@
               </a:spcAft>
             </a:pPr>
             <a:r>
-              <a:rPr sz="1000" b="1">
+              <a:rPr sz="919" b="1">
                 <a:solidFill>
                   <a:srgbClr val="22C55E"/>
                 </a:solidFill>
                 <a:latin typeface="Calibri"/>
               </a:rPr>
-              <a:t>Bậc ≥300 · CK 10%</a:t>
-            </a:r>
-          </a:p>
-        </p:txBody>
-      </p:sp>
-      <p:sp>
-        <p:nvSpPr>
-          <p:cNvPr id="79" name="TextBox 78"/>
+              <a:t>GAPIT mua ≥300 (−20%)  →  bán ĐL ≥300 (CK 10%)</a:t>
+            </a:r>
+          </a:p>
+        </p:txBody>
+      </p:sp>
+      <p:sp>
+        <p:nvSpPr>
+          <p:cNvPr id="48" name="TextBox 47"/>
           <p:cNvSpPr txBox="1"/>
           <p:nvPr/>
         </p:nvSpPr>
         <p:spPr>
           <a:xfrm>
-            <a:off x="9326880" y="2926079"/>
-            <a:ext cx="2377440" cy="731520"/>
+            <a:off x="612648" y="5138928"/>
+            <a:ext cx="3429000" cy="694944"/>
           </a:xfrm>
           <a:prstGeom prst="rect">
             <a:avLst/>
@@ -8394,21 +7125,39 @@
               </a:spcAft>
             </a:pPr>
             <a:r>
-              <a:rPr sz="930" b="0">
+              <a:rPr sz="860" b="0">
                 <a:solidFill>
                   <a:srgbClr val="4A5568"/>
                 </a:solidFill>
                 <a:latin typeface="Calibri"/>
               </a:rPr>
-              <a:t>ĐL mua: </a:t>
-            </a:r>
-            <a:r>
-              <a:rPr sz="930" b="1">
+              <a:t>Giá vốn GAPIT: </a:t>
+            </a:r>
+            <a:r>
+              <a:rPr sz="860" b="1">
                 <a:solidFill>
                   <a:srgbClr val="001A40"/>
                 </a:solidFill>
                 <a:latin typeface="Calibri"/>
               </a:rPr>
+              <a:t>1.592.000đ</a:t>
+            </a:r>
+            <a:r>
+              <a:rPr sz="860" b="0">
+                <a:solidFill>
+                  <a:srgbClr val="4A5568"/>
+                </a:solidFill>
+                <a:latin typeface="Calibri"/>
+              </a:rPr>
+              <a:t>   ·   ĐL/KHDN mua: </a:t>
+            </a:r>
+            <a:r>
+              <a:rPr sz="860" b="1">
+                <a:solidFill>
+                  <a:srgbClr val="001A40"/>
+                </a:solidFill>
+                <a:latin typeface="Calibri"/>
+              </a:rPr>
               <a:t>1.791.000đ</a:t>
             </a:r>
           </a:p>
@@ -8425,7 +7174,7 @@
               </a:spcAft>
             </a:pPr>
             <a:r>
-              <a:rPr sz="930" b="0">
+              <a:rPr sz="919" b="0">
                 <a:solidFill>
                   <a:srgbClr val="4A5568"/>
                 </a:solidFill>
@@ -8434,7 +7183,7 @@
               <a:t>Biên GAPIT: </a:t>
             </a:r>
             <a:r>
-              <a:rPr sz="930" b="1">
+              <a:rPr sz="919" b="1">
                 <a:solidFill>
                   <a:srgbClr val="F5862C"/>
                 </a:solidFill>
@@ -8449,23 +7198,23 @@
                 <a:spcPct val="103000"/>
               </a:lnSpc>
               <a:spcBef>
-                <a:spcPts val="200"/>
-              </a:spcBef>
-              <a:spcAft>
-                <a:spcPts val="0"/>
-              </a:spcAft>
-            </a:pPr>
-            <a:r>
-              <a:rPr sz="930" b="0">
+                <a:spcPts val="100"/>
+              </a:spcBef>
+              <a:spcAft>
+                <a:spcPts val="0"/>
+              </a:spcAft>
+            </a:pPr>
+            <a:r>
+              <a:rPr sz="919" b="0">
                 <a:solidFill>
                   <a:srgbClr val="4A5568"/>
                 </a:solidFill>
                 <a:latin typeface="Calibri"/>
               </a:rPr>
-              <a:t>Biên Đại lý: </a:t>
-            </a:r>
-            <a:r>
-              <a:rPr sz="930" b="1">
+              <a:t>Biên Đại lý/KHDN: </a:t>
+            </a:r>
+            <a:r>
+              <a:rPr sz="919" b="1">
                 <a:solidFill>
                   <a:srgbClr val="22C55E"/>
                 </a:solidFill>
@@ -8478,14 +7227,14 @@
       </p:sp>
       <p:sp>
         <p:nvSpPr>
-          <p:cNvPr id="80" name="Rounded Rectangle 79"/>
+          <p:cNvPr id="49" name="Rounded Rectangle 48"/>
           <p:cNvSpPr/>
           <p:nvPr/>
         </p:nvSpPr>
         <p:spPr>
           <a:xfrm>
-            <a:off x="9144000" y="3822191"/>
-            <a:ext cx="2651760" cy="1078992"/>
+            <a:off x="4242816" y="4663440"/>
+            <a:ext cx="3703320" cy="1207008"/>
           </a:xfrm>
           <a:prstGeom prst="roundRect">
             <a:avLst/>
@@ -8524,14 +7273,14 @@
       </p:sp>
       <p:sp>
         <p:nvSpPr>
-          <p:cNvPr id="81" name="Rectangle 80"/>
+          <p:cNvPr id="50" name="Rectangle 49"/>
           <p:cNvSpPr/>
           <p:nvPr/>
         </p:nvSpPr>
         <p:spPr>
           <a:xfrm>
-            <a:off x="9144000" y="3822191"/>
-            <a:ext cx="91440" cy="1078992"/>
+            <a:off x="4242816" y="4663440"/>
+            <a:ext cx="91440" cy="1207008"/>
           </a:xfrm>
           <a:prstGeom prst="rect">
             <a:avLst/>
@@ -8568,14 +7317,14 @@
       </p:sp>
       <p:sp>
         <p:nvSpPr>
-          <p:cNvPr id="82" name="TextBox 81"/>
+          <p:cNvPr id="51" name="TextBox 50"/>
           <p:cNvSpPr txBox="1"/>
           <p:nvPr/>
         </p:nvSpPr>
         <p:spPr>
           <a:xfrm>
-            <a:off x="9326880" y="3877055"/>
-            <a:ext cx="2377440" cy="237744"/>
+            <a:off x="4443983" y="4709160"/>
+            <a:ext cx="3429000" cy="420624"/>
           </a:xfrm>
           <a:prstGeom prst="rect">
             <a:avLst/>
@@ -8600,27 +7349,27 @@
               </a:spcAft>
             </a:pPr>
             <a:r>
-              <a:rPr sz="1000" b="1">
+              <a:rPr sz="919" b="1">
                 <a:solidFill>
                   <a:srgbClr val="F5862C"/>
                 </a:solidFill>
                 <a:latin typeface="Calibri"/>
               </a:rPr>
-              <a:t>Bậc 50–99 · CK 5%</a:t>
-            </a:r>
-          </a:p>
-        </p:txBody>
-      </p:sp>
-      <p:sp>
-        <p:nvSpPr>
-          <p:cNvPr id="83" name="TextBox 82"/>
+              <a:t>GAPIT mua ≥300 (−20%)  →  bán ĐL 50–99 (CK 5%)</a:t>
+            </a:r>
+          </a:p>
+        </p:txBody>
+      </p:sp>
+      <p:sp>
+        <p:nvSpPr>
+          <p:cNvPr id="52" name="TextBox 51"/>
           <p:cNvSpPr txBox="1"/>
           <p:nvPr/>
         </p:nvSpPr>
         <p:spPr>
           <a:xfrm>
-            <a:off x="9326880" y="4133087"/>
-            <a:ext cx="2377440" cy="731520"/>
+            <a:off x="4443983" y="5138928"/>
+            <a:ext cx="3429000" cy="694944"/>
           </a:xfrm>
           <a:prstGeom prst="rect">
             <a:avLst/>
@@ -8645,21 +7394,39 @@
               </a:spcAft>
             </a:pPr>
             <a:r>
-              <a:rPr sz="930" b="0">
+              <a:rPr sz="860" b="0">
                 <a:solidFill>
                   <a:srgbClr val="4A5568"/>
                 </a:solidFill>
                 <a:latin typeface="Calibri"/>
               </a:rPr>
-              <a:t>ĐL mua: </a:t>
-            </a:r>
-            <a:r>
-              <a:rPr sz="930" b="1">
+              <a:t>Giá vốn GAPIT: </a:t>
+            </a:r>
+            <a:r>
+              <a:rPr sz="860" b="1">
                 <a:solidFill>
                   <a:srgbClr val="001A40"/>
                 </a:solidFill>
                 <a:latin typeface="Calibri"/>
               </a:rPr>
+              <a:t>1.592.000đ</a:t>
+            </a:r>
+            <a:r>
+              <a:rPr sz="860" b="0">
+                <a:solidFill>
+                  <a:srgbClr val="4A5568"/>
+                </a:solidFill>
+                <a:latin typeface="Calibri"/>
+              </a:rPr>
+              <a:t>   ·   ĐL/KHDN mua: </a:t>
+            </a:r>
+            <a:r>
+              <a:rPr sz="860" b="1">
+                <a:solidFill>
+                  <a:srgbClr val="001A40"/>
+                </a:solidFill>
+                <a:latin typeface="Calibri"/>
+              </a:rPr>
               <a:t>1.890.500đ</a:t>
             </a:r>
           </a:p>
@@ -8676,7 +7443,7 @@
               </a:spcAft>
             </a:pPr>
             <a:r>
-              <a:rPr sz="930" b="0">
+              <a:rPr sz="919" b="0">
                 <a:solidFill>
                   <a:srgbClr val="4A5568"/>
                 </a:solidFill>
@@ -8685,7 +7452,7 @@
               <a:t>Biên GAPIT: </a:t>
             </a:r>
             <a:r>
-              <a:rPr sz="930" b="1">
+              <a:rPr sz="919" b="1">
                 <a:solidFill>
                   <a:srgbClr val="F5862C"/>
                 </a:solidFill>
@@ -8700,6 +7467,244 @@
                 <a:spcPct val="103000"/>
               </a:lnSpc>
               <a:spcBef>
+                <a:spcPts val="100"/>
+              </a:spcBef>
+              <a:spcAft>
+                <a:spcPts val="0"/>
+              </a:spcAft>
+            </a:pPr>
+            <a:r>
+              <a:rPr sz="919" b="0">
+                <a:solidFill>
+                  <a:srgbClr val="4A5568"/>
+                </a:solidFill>
+                <a:latin typeface="Calibri"/>
+              </a:rPr>
+              <a:t>Biên Đại lý/KHDN: </a:t>
+            </a:r>
+            <a:r>
+              <a:rPr sz="919" b="1">
+                <a:solidFill>
+                  <a:srgbClr val="22C55E"/>
+                </a:solidFill>
+                <a:latin typeface="Calibri"/>
+              </a:rPr>
+              <a:t>99.500đ (5%)</a:t>
+            </a:r>
+          </a:p>
+        </p:txBody>
+      </p:sp>
+      <p:sp>
+        <p:nvSpPr>
+          <p:cNvPr id="53" name="Rounded Rectangle 52"/>
+          <p:cNvSpPr/>
+          <p:nvPr/>
+        </p:nvSpPr>
+        <p:spPr>
+          <a:xfrm>
+            <a:off x="8074152" y="4663440"/>
+            <a:ext cx="3703320" cy="1207008"/>
+          </a:xfrm>
+          <a:prstGeom prst="roundRect">
+            <a:avLst/>
+          </a:prstGeom>
+          <a:solidFill>
+            <a:srgbClr val="FFFFFF"/>
+          </a:solidFill>
+          <a:ln w="15875">
+            <a:solidFill>
+              <a:srgbClr val="003F88"/>
+            </a:solidFill>
+          </a:ln>
+          <a:effectLst/>
+        </p:spPr>
+        <p:style>
+          <a:lnRef idx="1">
+            <a:schemeClr val="accent1"/>
+          </a:lnRef>
+          <a:fillRef idx="3">
+            <a:schemeClr val="accent1"/>
+          </a:fillRef>
+          <a:effectRef idx="2">
+            <a:schemeClr val="accent1"/>
+          </a:effectRef>
+          <a:fontRef idx="minor">
+            <a:schemeClr val="lt1"/>
+          </a:fontRef>
+        </p:style>
+        <p:txBody>
+          <a:bodyPr rtlCol="0" anchor="ctr"/>
+          <a:lstStyle/>
+          <a:p>
+            <a:pPr algn="ctr"/>
+          </a:p>
+        </p:txBody>
+      </p:sp>
+      <p:sp>
+        <p:nvSpPr>
+          <p:cNvPr id="54" name="Rectangle 53"/>
+          <p:cNvSpPr/>
+          <p:nvPr/>
+        </p:nvSpPr>
+        <p:spPr>
+          <a:xfrm>
+            <a:off x="8074152" y="4663440"/>
+            <a:ext cx="91440" cy="1207008"/>
+          </a:xfrm>
+          <a:prstGeom prst="rect">
+            <a:avLst/>
+          </a:prstGeom>
+          <a:solidFill>
+            <a:srgbClr val="003F88"/>
+          </a:solidFill>
+          <a:ln>
+            <a:noFill/>
+          </a:ln>
+          <a:effectLst/>
+        </p:spPr>
+        <p:style>
+          <a:lnRef idx="1">
+            <a:schemeClr val="accent1"/>
+          </a:lnRef>
+          <a:fillRef idx="3">
+            <a:schemeClr val="accent1"/>
+          </a:fillRef>
+          <a:effectRef idx="2">
+            <a:schemeClr val="accent1"/>
+          </a:effectRef>
+          <a:fontRef idx="minor">
+            <a:schemeClr val="lt1"/>
+          </a:fontRef>
+        </p:style>
+        <p:txBody>
+          <a:bodyPr rtlCol="0" anchor="ctr"/>
+          <a:lstStyle/>
+          <a:p>
+            <a:pPr algn="ctr"/>
+          </a:p>
+        </p:txBody>
+      </p:sp>
+      <p:sp>
+        <p:nvSpPr>
+          <p:cNvPr id="55" name="TextBox 54"/>
+          <p:cNvSpPr txBox="1"/>
+          <p:nvPr/>
+        </p:nvSpPr>
+        <p:spPr>
+          <a:xfrm>
+            <a:off x="8275320" y="4709160"/>
+            <a:ext cx="3429000" cy="420624"/>
+          </a:xfrm>
+          <a:prstGeom prst="rect">
+            <a:avLst/>
+          </a:prstGeom>
+          <a:noFill/>
+        </p:spPr>
+        <p:txBody>
+          <a:bodyPr wrap="square" anchor="t" lIns="45720" rIns="45720" tIns="18288" bIns="9144">
+            <a:spAutoFit/>
+          </a:bodyPr>
+          <a:lstStyle/>
+          <a:p>
+            <a:pPr algn="l">
+              <a:lnSpc>
+                <a:spcPct val="103000"/>
+              </a:lnSpc>
+              <a:spcBef>
+                <a:spcPts val="0"/>
+              </a:spcBef>
+              <a:spcAft>
+                <a:spcPts val="0"/>
+              </a:spcAft>
+            </a:pPr>
+            <a:r>
+              <a:rPr sz="919" b="1">
+                <a:solidFill>
+                  <a:srgbClr val="003F88"/>
+                </a:solidFill>
+                <a:latin typeface="Calibri"/>
+              </a:rPr>
+              <a:t>GAPIT mua 100–299 (−15%)  →  bán ĐL 100–299 (CK 8%)</a:t>
+            </a:r>
+          </a:p>
+        </p:txBody>
+      </p:sp>
+      <p:sp>
+        <p:nvSpPr>
+          <p:cNvPr id="56" name="TextBox 55"/>
+          <p:cNvSpPr txBox="1"/>
+          <p:nvPr/>
+        </p:nvSpPr>
+        <p:spPr>
+          <a:xfrm>
+            <a:off x="8275320" y="5138928"/>
+            <a:ext cx="3429000" cy="694944"/>
+          </a:xfrm>
+          <a:prstGeom prst="rect">
+            <a:avLst/>
+          </a:prstGeom>
+          <a:noFill/>
+        </p:spPr>
+        <p:txBody>
+          <a:bodyPr wrap="square" anchor="t" lIns="45720" rIns="45720" tIns="18288" bIns="9144">
+            <a:spAutoFit/>
+          </a:bodyPr>
+          <a:lstStyle/>
+          <a:p>
+            <a:pPr algn="l">
+              <a:lnSpc>
+                <a:spcPct val="103000"/>
+              </a:lnSpc>
+              <a:spcBef>
+                <a:spcPts val="0"/>
+              </a:spcBef>
+              <a:spcAft>
+                <a:spcPts val="0"/>
+              </a:spcAft>
+            </a:pPr>
+            <a:r>
+              <a:rPr sz="860" b="0">
+                <a:solidFill>
+                  <a:srgbClr val="4A5568"/>
+                </a:solidFill>
+                <a:latin typeface="Calibri"/>
+              </a:rPr>
+              <a:t>Giá vốn GAPIT: </a:t>
+            </a:r>
+            <a:r>
+              <a:rPr sz="860" b="1">
+                <a:solidFill>
+                  <a:srgbClr val="001A40"/>
+                </a:solidFill>
+                <a:latin typeface="Calibri"/>
+              </a:rPr>
+              <a:t>1.691.500đ</a:t>
+            </a:r>
+            <a:r>
+              <a:rPr sz="860" b="0">
+                <a:solidFill>
+                  <a:srgbClr val="4A5568"/>
+                </a:solidFill>
+                <a:latin typeface="Calibri"/>
+              </a:rPr>
+              <a:t>   ·   ĐL/KHDN mua: </a:t>
+            </a:r>
+            <a:r>
+              <a:rPr sz="860" b="1">
+                <a:solidFill>
+                  <a:srgbClr val="001A40"/>
+                </a:solidFill>
+                <a:latin typeface="Calibri"/>
+              </a:rPr>
+              <a:t>1.830.800đ</a:t>
+            </a:r>
+          </a:p>
+          <a:p>
+            <a:pPr algn="l">
+              <a:lnSpc>
+                <a:spcPct val="103000"/>
+              </a:lnSpc>
+              <a:spcBef>
                 <a:spcPts val="200"/>
               </a:spcBef>
               <a:spcAft>
@@ -8707,36 +7712,67 @@
               </a:spcAft>
             </a:pPr>
             <a:r>
-              <a:rPr sz="930" b="0">
+              <a:rPr sz="919" b="0">
                 <a:solidFill>
                   <a:srgbClr val="4A5568"/>
                 </a:solidFill>
                 <a:latin typeface="Calibri"/>
               </a:rPr>
-              <a:t>Biên Đại lý: </a:t>
-            </a:r>
-            <a:r>
-              <a:rPr sz="930" b="1">
+              <a:t>Biên GAPIT: </a:t>
+            </a:r>
+            <a:r>
+              <a:rPr sz="919" b="1">
+                <a:solidFill>
+                  <a:srgbClr val="F5862C"/>
+                </a:solidFill>
+                <a:latin typeface="Calibri"/>
+              </a:rPr>
+              <a:t>139.300đ (7%)</a:t>
+            </a:r>
+          </a:p>
+          <a:p>
+            <a:pPr algn="l">
+              <a:lnSpc>
+                <a:spcPct val="103000"/>
+              </a:lnSpc>
+              <a:spcBef>
+                <a:spcPts val="100"/>
+              </a:spcBef>
+              <a:spcAft>
+                <a:spcPts val="0"/>
+              </a:spcAft>
+            </a:pPr>
+            <a:r>
+              <a:rPr sz="919" b="0">
+                <a:solidFill>
+                  <a:srgbClr val="4A5568"/>
+                </a:solidFill>
+                <a:latin typeface="Calibri"/>
+              </a:rPr>
+              <a:t>Biên Đại lý/KHDN: </a:t>
+            </a:r>
+            <a:r>
+              <a:rPr sz="919" b="1">
                 <a:solidFill>
                   <a:srgbClr val="22C55E"/>
                 </a:solidFill>
                 <a:latin typeface="Calibri"/>
               </a:rPr>
-              <a:t>99.500đ (5%)</a:t>
-            </a:r>
-          </a:p>
-        </p:txBody>
-      </p:sp>
-      <p:sp>
-        <p:nvSpPr>
-          <p:cNvPr id="84" name="Rounded Rectangle 83"/>
+              <a:t>159.200đ (8%)</a:t>
+            </a:r>
+          </a:p>
+        </p:txBody>
+      </p:sp>
+      <p:sp>
+        <p:nvSpPr>
+          <p:cNvPr id="57" name="Rounded Rectangle 56"/>
           <p:cNvSpPr/>
           <p:nvPr/>
         </p:nvSpPr>
         <p:spPr>
           <a:xfrm>
-            <a:off x="411480" y="5440680"/>
-            <a:ext cx="11384280" cy="868680"/>
+            <a:off x="411480" y="5989320"/>
+            <a:ext cx="11384280" cy="530352"/>
           </a:xfrm>
           <a:prstGeom prst="roundRect">
             <a:avLst/>
@@ -8775,14 +7811,14 @@
       </p:sp>
       <p:sp>
         <p:nvSpPr>
-          <p:cNvPr id="85" name="TextBox 84"/>
+          <p:cNvPr id="58" name="TextBox 57"/>
           <p:cNvSpPr txBox="1"/>
           <p:nvPr/>
         </p:nvSpPr>
         <p:spPr>
           <a:xfrm>
-            <a:off x="594360" y="5504688"/>
-            <a:ext cx="11064240" cy="777240"/>
+            <a:off x="594360" y="6025896"/>
+            <a:ext cx="11064240" cy="457200"/>
           </a:xfrm>
           <a:prstGeom prst="rect">
             <a:avLst/>
@@ -8807,7 +7843,7 @@
               </a:spcAft>
             </a:pPr>
             <a:r>
-              <a:rPr sz="950" b="1">
+              <a:rPr sz="869" b="1">
                 <a:solidFill>
                   <a:srgbClr val="F5862C"/>
                 </a:solidFill>
@@ -8816,35 +7852,13 @@
               <a:t>Lưu ý: </a:t>
             </a:r>
             <a:r>
-              <a:rPr sz="950" b="0">
+              <a:rPr sz="869" b="0">
                 <a:solidFill>
                   <a:srgbClr val="4A5568"/>
                 </a:solidFill>
                 <a:latin typeface="Calibri"/>
               </a:rPr>
-              <a:t>“Tổng biên kênh ≈20%” suy ra từ giá zBusiness 12 tháng tại Phụ lục HĐ VNG–GAPIT; các gói khác (zCloud/zStyle…) theo Phụ lục tương ứng — cập nhật % thực tế khi có giá từng gói.</a:t>
-            </a:r>
-          </a:p>
-          <a:p>
-            <a:pPr algn="l">
-              <a:lnSpc>
-                <a:spcPct val="103000"/>
-              </a:lnSpc>
-              <a:spcBef>
-                <a:spcPts val="300"/>
-              </a:spcBef>
-              <a:spcAft>
-                <a:spcPts val="0"/>
-              </a:spcAft>
-            </a:pPr>
-            <a:r>
-              <a:rPr sz="950" b="0">
-                <a:solidFill>
-                  <a:srgbClr val="4A5568"/>
-                </a:solidFill>
-                <a:latin typeface="Calibri"/>
-              </a:rPr>
-              <a:t>Chiết khấu Đại lý cấp II tính trên Giá bán lẻ trực tiếp của Zalo (giá sàn công khai). Mã code đã mua: không hoàn/đổi (chính sách VNG). Đại lý không được bán công khai dưới giá sàn.</a:t>
+              <a:t>Chiết khấu tính trên Giá bán lẻ trực tiếp của Zalo (giá sàn công khai). Tổng biên kênh = chiết khấu GAPIT nhận từ VNG (15–20% theo SL GAPIT đặt); GAPIT giữ = phần còn lại sau khi cấp chiết khấu cho Đại lý/KHDN. GAPIT bán trực tiếp KHDN ở giá sàn → giữ trọn 15–20%. Mã code đã mua: không hoàn/đổi (chính sách VNG); không bán công khai dưới giá sàn. Số ví dụ theo zBusiness 12T — gói khác theo Phụ lục.</a:t>
             </a:r>
           </a:p>
         </p:txBody>

</xml_diff>